<commit_message>
Update CH12 sequence diagram with verified AIR and Experience flow
</commit_message>
<xml_diff>
--- a/documents/CH12-AIRManager-Sequence.pptx
+++ b/documents/CH12-AIRManager-Sequence.pptx
@@ -6,6 +6,7 @@
   </p:sldMasterIdLst>
   <p:sldIdLst>
     <p:sldId id="256" r:id="rId2"/>
+    <p:sldId id="257" r:id="rId3"/>
   </p:sldIdLst>
   <p:sldSz cx="12192000" cy="6858000"/>
   <p:notesSz cx="6858000" cy="9144000"/>
@@ -302,7 +303,7 @@
           <a:p>
             <a:fld id="{5BCAD085-E8A6-8845-BD4E-CB4CCA059FC4}" type="datetimeFigureOut">
               <a:rPr lang="en-US" smtClean="0"/>
-              <a:t>10/31/2026</a:t>
+              <a:t>11/1/2026</a:t>
             </a:fld>
             <a:endParaRPr lang="en-US"/>
           </a:p>
@@ -470,7 +471,7 @@
           <a:p>
             <a:fld id="{5BCAD085-E8A6-8845-BD4E-CB4CCA059FC4}" type="datetimeFigureOut">
               <a:rPr lang="en-US" smtClean="0"/>
-              <a:t>10/31/2026</a:t>
+              <a:t>11/1/2026</a:t>
             </a:fld>
             <a:endParaRPr lang="en-US"/>
           </a:p>
@@ -648,7 +649,7 @@
           <a:p>
             <a:fld id="{5BCAD085-E8A6-8845-BD4E-CB4CCA059FC4}" type="datetimeFigureOut">
               <a:rPr lang="en-US" smtClean="0"/>
-              <a:t>10/31/2026</a:t>
+              <a:t>11/1/2026</a:t>
             </a:fld>
             <a:endParaRPr lang="en-US"/>
           </a:p>
@@ -816,7 +817,7 @@
           <a:p>
             <a:fld id="{5BCAD085-E8A6-8845-BD4E-CB4CCA059FC4}" type="datetimeFigureOut">
               <a:rPr lang="en-US" smtClean="0"/>
-              <a:t>10/31/2026</a:t>
+              <a:t>11/1/2026</a:t>
             </a:fld>
             <a:endParaRPr lang="en-US"/>
           </a:p>
@@ -1061,7 +1062,7 @@
           <a:p>
             <a:fld id="{5BCAD085-E8A6-8845-BD4E-CB4CCA059FC4}" type="datetimeFigureOut">
               <a:rPr lang="en-US" smtClean="0"/>
-              <a:t>10/31/2026</a:t>
+              <a:t>11/1/2026</a:t>
             </a:fld>
             <a:endParaRPr lang="en-US"/>
           </a:p>
@@ -1346,7 +1347,7 @@
           <a:p>
             <a:fld id="{5BCAD085-E8A6-8845-BD4E-CB4CCA059FC4}" type="datetimeFigureOut">
               <a:rPr lang="en-US" smtClean="0"/>
-              <a:t>10/31/2026</a:t>
+              <a:t>11/1/2026</a:t>
             </a:fld>
             <a:endParaRPr lang="en-US"/>
           </a:p>
@@ -1765,7 +1766,7 @@
           <a:p>
             <a:fld id="{5BCAD085-E8A6-8845-BD4E-CB4CCA059FC4}" type="datetimeFigureOut">
               <a:rPr lang="en-US" smtClean="0"/>
-              <a:t>10/31/2026</a:t>
+              <a:t>11/1/2026</a:t>
             </a:fld>
             <a:endParaRPr lang="en-US"/>
           </a:p>
@@ -1882,7 +1883,7 @@
           <a:p>
             <a:fld id="{5BCAD085-E8A6-8845-BD4E-CB4CCA059FC4}" type="datetimeFigureOut">
               <a:rPr lang="en-US" smtClean="0"/>
-              <a:t>10/31/2026</a:t>
+              <a:t>11/1/2026</a:t>
             </a:fld>
             <a:endParaRPr lang="en-US"/>
           </a:p>
@@ -1977,7 +1978,7 @@
           <a:p>
             <a:fld id="{5BCAD085-E8A6-8845-BD4E-CB4CCA059FC4}" type="datetimeFigureOut">
               <a:rPr lang="en-US" smtClean="0"/>
-              <a:t>10/31/2026</a:t>
+              <a:t>11/1/2026</a:t>
             </a:fld>
             <a:endParaRPr lang="en-US"/>
           </a:p>
@@ -2252,7 +2253,7 @@
           <a:p>
             <a:fld id="{5BCAD085-E8A6-8845-BD4E-CB4CCA059FC4}" type="datetimeFigureOut">
               <a:rPr lang="en-US" smtClean="0"/>
-              <a:t>10/31/2026</a:t>
+              <a:t>11/1/2026</a:t>
             </a:fld>
             <a:endParaRPr lang="en-US"/>
           </a:p>
@@ -2504,7 +2505,7 @@
           <a:p>
             <a:fld id="{5BCAD085-E8A6-8845-BD4E-CB4CCA059FC4}" type="datetimeFigureOut">
               <a:rPr lang="en-US" smtClean="0"/>
-              <a:t>10/31/2026</a:t>
+              <a:t>11/1/2026</a:t>
             </a:fld>
             <a:endParaRPr lang="en-US"/>
           </a:p>
@@ -2715,7 +2716,7 @@
           <a:p>
             <a:fld id="{5BCAD085-E8A6-8845-BD4E-CB4CCA059FC4}" type="datetimeFigureOut">
               <a:rPr lang="en-US" smtClean="0"/>
-              <a:t>10/31/2026</a:t>
+              <a:t>11/1/2026</a:t>
             </a:fld>
             <a:endParaRPr lang="en-US"/>
           </a:p>
@@ -3415,7 +3416,7 @@
               </a:defRPr>
             </a:pPr>
             <a:r>
-              <a:t>実線：観測した接続・実行</a:t>
+              <a:t>実線：接続・移動を実機確認</a:t>
             </a:r>
           </a:p>
         </p:txBody>
@@ -3437,7 +3438,7 @@
             </a:avLst>
           </a:prstGeom>
           <a:solidFill>
-            <a:srgbClr val="FFF7E1"/>
+            <a:srgbClr val="E3F6F4"/>
           </a:solidFill>
           <a:ln>
             <a:noFill/>
@@ -3500,7 +3501,12 @@
               </a:defRPr>
             </a:pPr>
             <a:r>
-              <a:t>破線：内部仕様は要コード照合</a:t>
+              <a:rPr>
+                <a:solidFill>
+                  <a:srgbClr val="077979"/>
+                </a:solidFill>
+              </a:rPr>
+              <a:t>破線：返信（コード照合済）</a:t>
             </a:r>
           </a:p>
         </p:txBody>
@@ -6288,7 +6294,7 @@
           </a:prstGeom>
           <a:ln w="17145">
             <a:solidFill>
-              <a:srgbClr val="B5751E"/>
+              <a:srgbClr val="077979"/>
             </a:solidFill>
             <a:prstDash val="dash"/>
           </a:ln>
@@ -6323,10 +6329,12 @@
             <a:avLst/>
           </a:prstGeom>
           <a:solidFill>
-            <a:srgbClr val="B5751E"/>
+            <a:srgbClr val="077979"/>
           </a:solidFill>
           <a:ln>
-            <a:noFill/>
+            <a:solidFill>
+              <a:srgbClr val="077979"/>
+            </a:solidFill>
           </a:ln>
         </p:spPr>
         <p:style>
@@ -6386,7 +6394,12 @@
               </a:defRPr>
             </a:pPr>
             <a:r>
-              <a:t>⑧ target_positionを返送（設計記録）</a:t>
+              <a:rPr>
+                <a:solidFill>
+                  <a:srgbClr val="077979"/>
+                </a:solidFill>
+              </a:rPr>
+              <a:t>⑧ 目標座標を返信（C++照合済）</a:t>
             </a:r>
           </a:p>
         </p:txBody>
@@ -6662,7 +6675,7 @@
               </a:defRPr>
             </a:pPr>
             <a:r>
-              <a:t>AIR：目標位置の算出／管理</a:t>
+              <a:t>AIR：Human_1基準の目標座標計算</a:t>
             </a:r>
           </a:p>
           <a:p>
@@ -6678,7 +6691,7 @@
               </a:defRPr>
             </a:pPr>
             <a:r>
-              <a:t>Unity：AI_1の移動反映</a:t>
+              <a:t>Unity：返信座標でAI_1位置更新</a:t>
             </a:r>
           </a:p>
         </p:txBody>
@@ -6923,7 +6936,7 @@
             </a:avLst>
           </a:prstGeom>
           <a:solidFill>
-            <a:srgbClr val="FFF7E1"/>
+            <a:srgbClr val="E3F6F4"/>
           </a:solidFill>
           <a:ln w="10160">
             <a:solidFill>
@@ -6971,7 +6984,7 @@
             </a:avLst>
           </a:prstGeom>
           <a:solidFill>
-            <a:srgbClr val="B5751E"/>
+            <a:srgbClr val="077979"/>
           </a:solidFill>
           <a:ln>
             <a:noFill/>
@@ -7034,7 +7047,12 @@
               </a:defRPr>
             </a:pPr>
             <a:r>
-              <a:t>要照合</a:t>
+              <a:rPr>
+                <a:solidFill>
+                  <a:srgbClr val="FFFFFF"/>
+                </a:solidFill>
+              </a:rPr>
+              <a:t>コード照合</a:t>
             </a:r>
           </a:p>
         </p:txBody>
@@ -7073,7 +7091,7 @@
               </a:defRPr>
             </a:pPr>
             <a:r>
-              <a:t>Human_1の現在位置送信・AIR返信形式はコード照合待ち</a:t>
+              <a:t>Unity→AIR：位置x/y/z・yaw・方向を送信</a:t>
             </a:r>
           </a:p>
           <a:p>
@@ -7089,7 +7107,7 @@
               </a:defRPr>
             </a:pPr>
             <a:r>
-              <a:t>Verification / Experienceは今回の成功判定に含めない</a:t>
+              <a:t>AIR→Unity：目標座標JSONを返信</a:t>
             </a:r>
           </a:p>
         </p:txBody>
@@ -7128,11 +7146,3464 @@
               </a:defRPr>
             </a:pPr>
             <a:r>
-              <a:t>注：⑦の関数呼出しは確認済み。Human_1の座標送信・⑧のAIR計算と返信は過去の設計記録に基づく概念表現（詳細未確認）。</a:t>
-            </a:r>
-          </a:p>
-        </p:txBody>
-      </p:sp>
+              <a:t>注：⑦〜⑨はC#・C++ソースで照合済み。AIR Managerは座標を算出・返信し、UnityがAI_1の位置を更新する。⑩〜⑫は2枚目。</a:t>
+            </a:r>
+          </a:p>
+        </p:txBody>
+      </p:sp>
+    </p:spTree>
+  </p:cSld>
+  <p:clrMapOvr>
+    <a:masterClrMapping/>
+  </p:clrMapOvr>
+</p:sld>
+</file>
+
+<file path=ppt/slides/slide2.xml><?xml version="1.0" encoding="utf-8"?>
+<p:sld xmlns:a="http://schemas.openxmlformats.org/drawingml/2006/main" xmlns:r="http://schemas.openxmlformats.org/officeDocument/2006/relationships" xmlns:p="http://schemas.openxmlformats.org/presentationml/2006/main">
+  <p:cSld>
+    <p:spTree>
+      <p:nvGrpSpPr>
+        <p:cNvPr id="1" name=""/>
+        <p:cNvGrpSpPr/>
+        <p:nvPr/>
+      </p:nvGrpSpPr>
+      <p:grpSpPr>
+        <a:xfrm>
+          <a:off x="0" y="0"/>
+          <a:ext cx="0" cy="0"/>
+          <a:chOff x="0" y="0"/>
+          <a:chExt cx="0" cy="0"/>
+        </a:xfrm>
+      </p:grpSpPr>
+      <p:sp>
+        <p:nvSpPr>
+          <p:cNvPr id="2" name="Rectangle 1"/>
+          <p:cNvSpPr/>
+          <p:nvPr/>
+        </p:nvSpPr>
+        <p:spPr>
+          <a:xfrm>
+            <a:off x="0" y="0"/>
+            <a:ext cx="12191999" cy="6858000"/>
+          </a:xfrm>
+          <a:prstGeom prst="rect">
+            <a:avLst/>
+          </a:prstGeom>
+          <a:solidFill>
+            <a:srgbClr val="FFFFFF"/>
+          </a:solidFill>
+          <a:ln>
+            <a:noFill/>
+          </a:ln>
+        </p:spPr>
+        <p:style>
+          <a:lnRef idx="1">
+            <a:schemeClr val="accent1"/>
+          </a:lnRef>
+          <a:fillRef idx="3">
+            <a:schemeClr val="accent1"/>
+          </a:fillRef>
+          <a:effectRef idx="2">
+            <a:schemeClr val="accent1"/>
+          </a:effectRef>
+          <a:fontRef idx="minor">
+            <a:schemeClr val="lt1"/>
+          </a:fontRef>
+        </p:style>
+        <p:txBody>
+          <a:bodyPr rtlCol="0" anchor="ctr"/>
+          <a:lstStyle/>
+          <a:p>
+            <a:pPr algn="ctr"/>
+            <a:endParaRPr/>
+          </a:p>
+        </p:txBody>
+      </p:sp>
+      <p:sp>
+        <p:nvSpPr>
+          <p:cNvPr id="3" name="Rectangle 2"/>
+          <p:cNvSpPr/>
+          <p:nvPr/>
+        </p:nvSpPr>
+        <p:spPr>
+          <a:xfrm>
+            <a:off x="0" y="0"/>
+            <a:ext cx="77724" cy="6858000"/>
+          </a:xfrm>
+          <a:prstGeom prst="rect">
+            <a:avLst/>
+          </a:prstGeom>
+          <a:solidFill>
+            <a:srgbClr val="122E4E"/>
+          </a:solidFill>
+          <a:ln>
+            <a:noFill/>
+          </a:ln>
+        </p:spPr>
+        <p:style>
+          <a:lnRef idx="1">
+            <a:schemeClr val="accent1"/>
+          </a:lnRef>
+          <a:fillRef idx="3">
+            <a:schemeClr val="accent1"/>
+          </a:fillRef>
+          <a:effectRef idx="2">
+            <a:schemeClr val="accent1"/>
+          </a:effectRef>
+          <a:fontRef idx="minor">
+            <a:schemeClr val="lt1"/>
+          </a:fontRef>
+        </p:style>
+        <p:txBody>
+          <a:bodyPr rtlCol="0" anchor="ctr"/>
+          <a:lstStyle/>
+          <a:p>
+            <a:pPr algn="ctr"/>
+            <a:endParaRPr/>
+          </a:p>
+        </p:txBody>
+      </p:sp>
+      <p:sp>
+        <p:nvSpPr>
+          <p:cNvPr id="4" name="Rectangle 3"/>
+          <p:cNvSpPr/>
+          <p:nvPr/>
+        </p:nvSpPr>
+        <p:spPr>
+          <a:xfrm>
+            <a:off x="347472" y="283464"/>
+            <a:ext cx="91440" cy="402336"/>
+          </a:xfrm>
+          <a:prstGeom prst="rect">
+            <a:avLst/>
+          </a:prstGeom>
+          <a:solidFill>
+            <a:srgbClr val="077979"/>
+          </a:solidFill>
+          <a:ln>
+            <a:noFill/>
+          </a:ln>
+        </p:spPr>
+        <p:style>
+          <a:lnRef idx="1">
+            <a:schemeClr val="accent1"/>
+          </a:lnRef>
+          <a:fillRef idx="3">
+            <a:schemeClr val="accent1"/>
+          </a:fillRef>
+          <a:effectRef idx="2">
+            <a:schemeClr val="accent1"/>
+          </a:effectRef>
+          <a:fontRef idx="minor">
+            <a:schemeClr val="lt1"/>
+          </a:fontRef>
+        </p:style>
+        <p:txBody>
+          <a:bodyPr rtlCol="0" anchor="ctr"/>
+          <a:lstStyle/>
+          <a:p>
+            <a:pPr algn="ctr"/>
+            <a:endParaRPr/>
+          </a:p>
+        </p:txBody>
+      </p:sp>
+      <p:sp>
+        <p:nvSpPr>
+          <p:cNvPr id="5" name="TextBox 4"/>
+          <p:cNvSpPr txBox="1"/>
+          <p:nvPr/>
+        </p:nvSpPr>
+        <p:spPr>
+          <a:xfrm>
+            <a:off x="576072" y="228600"/>
+            <a:ext cx="11109960" cy="521207"/>
+          </a:xfrm>
+          <a:prstGeom prst="rect">
+            <a:avLst/>
+          </a:prstGeom>
+          <a:noFill/>
+        </p:spPr>
+        <p:txBody>
+          <a:bodyPr wrap="square" lIns="0" tIns="0" rIns="0" bIns="0" anchor="ctr">
+            <a:spAutoFit/>
+          </a:bodyPr>
+          <a:lstStyle/>
+          <a:p>
+            <a:pPr algn="l">
+              <a:spcBef>
+                <a:spcPts val="0"/>
+              </a:spcBef>
+              <a:spcAft>
+                <a:spcPts val="0"/>
+              </a:spcAft>
+              <a:defRPr sz="2280" b="1">
+                <a:solidFill>
+                  <a:srgbClr val="122E4E"/>
+                </a:solidFill>
+                <a:latin typeface="Noto Sans CJK JP"/>
+              </a:defRPr>
+            </a:pPr>
+            <a:r>
+              <a:t>AI_1移動後：Verification・Human Evaluation・Experience記録</a:t>
+            </a:r>
+          </a:p>
+        </p:txBody>
+      </p:sp>
+      <p:sp>
+        <p:nvSpPr>
+          <p:cNvPr id="6" name="TextBox 5"/>
+          <p:cNvSpPr txBox="1"/>
+          <p:nvPr/>
+        </p:nvSpPr>
+        <p:spPr>
+          <a:xfrm>
+            <a:off x="594360" y="777240"/>
+            <a:ext cx="11064240" cy="256032"/>
+          </a:xfrm>
+          <a:prstGeom prst="rect">
+            <a:avLst/>
+          </a:prstGeom>
+          <a:noFill/>
+        </p:spPr>
+        <p:txBody>
+          <a:bodyPr wrap="square" lIns="0" tIns="0" rIns="0" bIns="0" anchor="ctr">
+            <a:spAutoFit/>
+          </a:bodyPr>
+          <a:lstStyle/>
+          <a:p>
+            <a:pPr algn="l">
+              <a:spcBef>
+                <a:spcPts val="0"/>
+              </a:spcBef>
+              <a:spcAft>
+                <a:spcPts val="0"/>
+              </a:spcAft>
+              <a:defRPr sz="1080" b="0">
+                <a:solidFill>
+                  <a:srgbClr val="5B6E82"/>
+                </a:solidFill>
+                <a:latin typeface="Noto Sans CJK JP"/>
+              </a:defRPr>
+            </a:pPr>
+            <a:r>
+              <a:t>CH12 §10.8  |  UMLシーケンス図（続編 ⑩〜⑫）  |  実機検証：2026-10-31 23:53 JST</a:t>
+            </a:r>
+          </a:p>
+        </p:txBody>
+      </p:sp>
+      <p:cxnSp>
+        <p:nvCxnSpPr>
+          <p:cNvPr id="7" name="Connector 6"/>
+          <p:cNvCxnSpPr/>
+          <p:nvPr/>
+        </p:nvCxnSpPr>
+        <p:spPr>
+          <a:xfrm>
+            <a:off x="484632" y="1097280"/>
+            <a:ext cx="11237976" cy="0"/>
+          </a:xfrm>
+          <a:prstGeom prst="line">
+            <a:avLst/>
+          </a:prstGeom>
+          <a:ln w="12700">
+            <a:solidFill>
+              <a:srgbClr val="DFE9F2"/>
+            </a:solidFill>
+          </a:ln>
+        </p:spPr>
+        <p:style>
+          <a:lnRef idx="2">
+            <a:schemeClr val="accent1"/>
+          </a:lnRef>
+          <a:fillRef idx="0">
+            <a:schemeClr val="accent1"/>
+          </a:fillRef>
+          <a:effectRef idx="1">
+            <a:schemeClr val="accent1"/>
+          </a:effectRef>
+          <a:fontRef idx="minor">
+            <a:schemeClr val="tx1"/>
+          </a:fontRef>
+        </p:style>
+      </p:cxnSp>
+      <p:sp>
+        <p:nvSpPr>
+          <p:cNvPr id="8" name="Rounded Rectangle 7"/>
+          <p:cNvSpPr/>
+          <p:nvPr/>
+        </p:nvSpPr>
+        <p:spPr>
+          <a:xfrm>
+            <a:off x="7680960" y="1207008"/>
+            <a:ext cx="1938528" cy="265176"/>
+          </a:xfrm>
+          <a:prstGeom prst="roundRect">
+            <a:avLst>
+              <a:gd name="adj" fmla="val 13000"/>
+            </a:avLst>
+          </a:prstGeom>
+          <a:solidFill>
+            <a:srgbClr val="E3F6F4"/>
+          </a:solidFill>
+          <a:ln>
+            <a:noFill/>
+          </a:ln>
+        </p:spPr>
+        <p:style>
+          <a:lnRef idx="1">
+            <a:schemeClr val="accent1"/>
+          </a:lnRef>
+          <a:fillRef idx="3">
+            <a:schemeClr val="accent1"/>
+          </a:fillRef>
+          <a:effectRef idx="2">
+            <a:schemeClr val="accent1"/>
+          </a:effectRef>
+          <a:fontRef idx="minor">
+            <a:schemeClr val="lt1"/>
+          </a:fontRef>
+        </p:style>
+        <p:txBody>
+          <a:bodyPr rtlCol="0" anchor="ctr"/>
+          <a:lstStyle/>
+          <a:p>
+            <a:pPr algn="ctr"/>
+            <a:endParaRPr/>
+          </a:p>
+        </p:txBody>
+      </p:sp>
+      <p:sp>
+        <p:nvSpPr>
+          <p:cNvPr id="9" name="TextBox 8"/>
+          <p:cNvSpPr txBox="1"/>
+          <p:nvPr/>
+        </p:nvSpPr>
+        <p:spPr>
+          <a:xfrm>
+            <a:off x="7735824" y="1216152"/>
+            <a:ext cx="1828800" cy="246888"/>
+          </a:xfrm>
+          <a:prstGeom prst="rect">
+            <a:avLst/>
+          </a:prstGeom>
+          <a:noFill/>
+        </p:spPr>
+        <p:txBody>
+          <a:bodyPr wrap="square" lIns="0" tIns="0" rIns="0" bIns="0" anchor="ctr">
+            <a:spAutoFit/>
+          </a:bodyPr>
+          <a:lstStyle/>
+          <a:p>
+            <a:pPr algn="ctr">
+              <a:spcBef>
+                <a:spcPts val="0"/>
+              </a:spcBef>
+              <a:spcAft>
+                <a:spcPts val="0"/>
+              </a:spcAft>
+              <a:defRPr sz="930" b="1">
+                <a:solidFill>
+                  <a:srgbClr val="077979"/>
+                </a:solidFill>
+                <a:latin typeface="Noto Sans CJK JP"/>
+              </a:defRPr>
+            </a:pPr>
+            <a:r>
+              <a:t>実線：コード照合済み</a:t>
+            </a:r>
+          </a:p>
+        </p:txBody>
+      </p:sp>
+      <p:sp>
+        <p:nvSpPr>
+          <p:cNvPr id="10" name="Rounded Rectangle 9"/>
+          <p:cNvSpPr/>
+          <p:nvPr/>
+        </p:nvSpPr>
+        <p:spPr>
+          <a:xfrm>
+            <a:off x="9738360" y="1207008"/>
+            <a:ext cx="1938528" cy="265176"/>
+          </a:xfrm>
+          <a:prstGeom prst="roundRect">
+            <a:avLst>
+              <a:gd name="adj" fmla="val 13000"/>
+            </a:avLst>
+          </a:prstGeom>
+          <a:solidFill>
+            <a:srgbClr val="FFF7E1"/>
+          </a:solidFill>
+          <a:ln>
+            <a:noFill/>
+          </a:ln>
+        </p:spPr>
+        <p:style>
+          <a:lnRef idx="1">
+            <a:schemeClr val="accent1"/>
+          </a:lnRef>
+          <a:fillRef idx="3">
+            <a:schemeClr val="accent1"/>
+          </a:fillRef>
+          <a:effectRef idx="2">
+            <a:schemeClr val="accent1"/>
+          </a:effectRef>
+          <a:fontRef idx="minor">
+            <a:schemeClr val="lt1"/>
+          </a:fontRef>
+        </p:style>
+        <p:txBody>
+          <a:bodyPr rtlCol="0" anchor="ctr"/>
+          <a:lstStyle/>
+          <a:p>
+            <a:pPr algn="ctr"/>
+            <a:endParaRPr/>
+          </a:p>
+        </p:txBody>
+      </p:sp>
+      <p:sp>
+        <p:nvSpPr>
+          <p:cNvPr id="11" name="TextBox 10"/>
+          <p:cNvSpPr txBox="1"/>
+          <p:nvPr/>
+        </p:nvSpPr>
+        <p:spPr>
+          <a:xfrm>
+            <a:off x="9793224" y="1216152"/>
+            <a:ext cx="1828800" cy="246888"/>
+          </a:xfrm>
+          <a:prstGeom prst="rect">
+            <a:avLst/>
+          </a:prstGeom>
+          <a:noFill/>
+        </p:spPr>
+        <p:txBody>
+          <a:bodyPr wrap="square" lIns="0" tIns="0" rIns="0" bIns="0" anchor="ctr">
+            <a:spAutoFit/>
+          </a:bodyPr>
+          <a:lstStyle/>
+          <a:p>
+            <a:pPr algn="ctr">
+              <a:spcBef>
+                <a:spcPts val="0"/>
+              </a:spcBef>
+              <a:spcAft>
+                <a:spcPts val="0"/>
+              </a:spcAft>
+              <a:defRPr sz="900" b="1">
+                <a:solidFill>
+                  <a:srgbClr val="B5751E"/>
+                </a:solidFill>
+                <a:latin typeface="Noto Sans CJK JP"/>
+              </a:defRPr>
+            </a:pPr>
+            <a:r>
+              <a:t>右方向：実機確認済み</a:t>
+            </a:r>
+          </a:p>
+        </p:txBody>
+      </p:sp>
+      <p:sp>
+        <p:nvSpPr>
+          <p:cNvPr id="12" name="Rounded Rectangle 11"/>
+          <p:cNvSpPr/>
+          <p:nvPr/>
+        </p:nvSpPr>
+        <p:spPr>
+          <a:xfrm>
+            <a:off x="374904" y="1600200"/>
+            <a:ext cx="1700784" cy="704088"/>
+          </a:xfrm>
+          <a:prstGeom prst="roundRect">
+            <a:avLst>
+              <a:gd name="adj" fmla="val 13000"/>
+            </a:avLst>
+          </a:prstGeom>
+          <a:solidFill>
+            <a:srgbClr val="EDF5FD"/>
+          </a:solidFill>
+          <a:ln w="15240">
+            <a:solidFill>
+              <a:srgbClr val="2E6FAF"/>
+            </a:solidFill>
+          </a:ln>
+        </p:spPr>
+        <p:style>
+          <a:lnRef idx="1">
+            <a:schemeClr val="accent1"/>
+          </a:lnRef>
+          <a:fillRef idx="3">
+            <a:schemeClr val="accent1"/>
+          </a:fillRef>
+          <a:effectRef idx="2">
+            <a:schemeClr val="accent1"/>
+          </a:effectRef>
+          <a:fontRef idx="minor">
+            <a:schemeClr val="lt1"/>
+          </a:fontRef>
+        </p:style>
+        <p:txBody>
+          <a:bodyPr rtlCol="0" anchor="ctr"/>
+          <a:lstStyle/>
+          <a:p>
+            <a:pPr algn="ctr"/>
+            <a:endParaRPr/>
+          </a:p>
+        </p:txBody>
+      </p:sp>
+      <p:sp>
+        <p:nvSpPr>
+          <p:cNvPr id="13" name="TextBox 12"/>
+          <p:cNvSpPr txBox="1"/>
+          <p:nvPr/>
+        </p:nvSpPr>
+        <p:spPr>
+          <a:xfrm>
+            <a:off x="393192" y="1636776"/>
+            <a:ext cx="1664208" cy="292608"/>
+          </a:xfrm>
+          <a:prstGeom prst="rect">
+            <a:avLst/>
+          </a:prstGeom>
+          <a:noFill/>
+        </p:spPr>
+        <p:txBody>
+          <a:bodyPr wrap="square" lIns="0" tIns="0" rIns="0" bIns="0" anchor="ctr">
+            <a:spAutoFit/>
+          </a:bodyPr>
+          <a:lstStyle/>
+          <a:p>
+            <a:pPr algn="ctr">
+              <a:spcBef>
+                <a:spcPts val="0"/>
+              </a:spcBef>
+              <a:spcAft>
+                <a:spcPts val="0"/>
+              </a:spcAft>
+              <a:defRPr sz="1200" b="1">
+                <a:solidFill>
+                  <a:srgbClr val="122E4E"/>
+                </a:solidFill>
+                <a:latin typeface="Noto Sans CJK JP"/>
+              </a:defRPr>
+            </a:pPr>
+            <a:r>
+              <a:t>Unity</a:t>
+            </a:r>
+          </a:p>
+        </p:txBody>
+      </p:sp>
+      <p:sp>
+        <p:nvSpPr>
+          <p:cNvPr id="14" name="TextBox 13"/>
+          <p:cNvSpPr txBox="1"/>
+          <p:nvPr/>
+        </p:nvSpPr>
+        <p:spPr>
+          <a:xfrm>
+            <a:off x="393192" y="1947672"/>
+            <a:ext cx="1664208" cy="228600"/>
+          </a:xfrm>
+          <a:prstGeom prst="rect">
+            <a:avLst/>
+          </a:prstGeom>
+          <a:noFill/>
+        </p:spPr>
+        <p:txBody>
+          <a:bodyPr wrap="square" lIns="0" tIns="0" rIns="0" bIns="0" anchor="ctr">
+            <a:spAutoFit/>
+          </a:bodyPr>
+          <a:lstStyle/>
+          <a:p>
+            <a:pPr algn="ctr">
+              <a:spcBef>
+                <a:spcPts val="0"/>
+              </a:spcBef>
+              <a:spcAft>
+                <a:spcPts val="0"/>
+              </a:spcAft>
+              <a:defRPr sz="930" b="0">
+                <a:solidFill>
+                  <a:srgbClr val="5B6E82"/>
+                </a:solidFill>
+                <a:latin typeface="Noto Sans CJK JP"/>
+              </a:defRPr>
+            </a:pPr>
+            <a:r>
+              <a:t>TcpSpeechReceiver</a:t>
+            </a:r>
+          </a:p>
+        </p:txBody>
+      </p:sp>
+      <p:sp>
+        <p:nvSpPr>
+          <p:cNvPr id="16" name="Rounded Rectangle 15"/>
+          <p:cNvSpPr/>
+          <p:nvPr/>
+        </p:nvSpPr>
+        <p:spPr>
+          <a:xfrm>
+            <a:off x="2286000" y="1600200"/>
+            <a:ext cx="1700784" cy="704088"/>
+          </a:xfrm>
+          <a:prstGeom prst="roundRect">
+            <a:avLst>
+              <a:gd name="adj" fmla="val 13000"/>
+            </a:avLst>
+          </a:prstGeom>
+          <a:solidFill>
+            <a:srgbClr val="E3F6F4"/>
+          </a:solidFill>
+          <a:ln w="15240">
+            <a:solidFill>
+              <a:srgbClr val="077979"/>
+            </a:solidFill>
+          </a:ln>
+        </p:spPr>
+        <p:style>
+          <a:lnRef idx="1">
+            <a:schemeClr val="accent1"/>
+          </a:lnRef>
+          <a:fillRef idx="3">
+            <a:schemeClr val="accent1"/>
+          </a:fillRef>
+          <a:effectRef idx="2">
+            <a:schemeClr val="accent1"/>
+          </a:effectRef>
+          <a:fontRef idx="minor">
+            <a:schemeClr val="lt1"/>
+          </a:fontRef>
+        </p:style>
+        <p:txBody>
+          <a:bodyPr rtlCol="0" anchor="ctr"/>
+          <a:lstStyle/>
+          <a:p>
+            <a:pPr algn="ctr"/>
+            <a:endParaRPr/>
+          </a:p>
+        </p:txBody>
+      </p:sp>
+      <p:sp>
+        <p:nvSpPr>
+          <p:cNvPr id="17" name="TextBox 16"/>
+          <p:cNvSpPr txBox="1"/>
+          <p:nvPr/>
+        </p:nvSpPr>
+        <p:spPr>
+          <a:xfrm>
+            <a:off x="2304288" y="1636776"/>
+            <a:ext cx="1664208" cy="292608"/>
+          </a:xfrm>
+          <a:prstGeom prst="rect">
+            <a:avLst/>
+          </a:prstGeom>
+          <a:noFill/>
+        </p:spPr>
+        <p:txBody>
+          <a:bodyPr wrap="square" lIns="0" tIns="0" rIns="0" bIns="0" anchor="ctr">
+            <a:spAutoFit/>
+          </a:bodyPr>
+          <a:lstStyle/>
+          <a:p>
+            <a:pPr algn="ctr">
+              <a:spcBef>
+                <a:spcPts val="0"/>
+              </a:spcBef>
+              <a:spcAft>
+                <a:spcPts val="0"/>
+              </a:spcAft>
+              <a:defRPr sz="1200" b="1">
+                <a:solidFill>
+                  <a:srgbClr val="122E4E"/>
+                </a:solidFill>
+                <a:latin typeface="Noto Sans CJK JP"/>
+              </a:defRPr>
+            </a:pPr>
+            <a:r>
+              <a:t>ActionVerifier</a:t>
+            </a:r>
+          </a:p>
+        </p:txBody>
+      </p:sp>
+      <p:sp>
+        <p:nvSpPr>
+          <p:cNvPr id="18" name="TextBox 17"/>
+          <p:cNvSpPr txBox="1"/>
+          <p:nvPr/>
+        </p:nvSpPr>
+        <p:spPr>
+          <a:xfrm>
+            <a:off x="2304288" y="1947672"/>
+            <a:ext cx="1664208" cy="228600"/>
+          </a:xfrm>
+          <a:prstGeom prst="rect">
+            <a:avLst/>
+          </a:prstGeom>
+          <a:noFill/>
+        </p:spPr>
+        <p:txBody>
+          <a:bodyPr wrap="square" lIns="0" tIns="0" rIns="0" bIns="0" anchor="ctr">
+            <a:spAutoFit/>
+          </a:bodyPr>
+          <a:lstStyle/>
+          <a:p>
+            <a:pPr algn="ctr">
+              <a:spcBef>
+                <a:spcPts val="0"/>
+              </a:spcBef>
+              <a:spcAft>
+                <a:spcPts val="0"/>
+              </a:spcAft>
+              <a:defRPr sz="930" b="0">
+                <a:solidFill>
+                  <a:srgbClr val="5B6E82"/>
+                </a:solidFill>
+                <a:latin typeface="Noto Sans CJK JP"/>
+              </a:defRPr>
+            </a:pPr>
+            <a:r>
+              <a:t>期待位置／位置誤差</a:t>
+            </a:r>
+          </a:p>
+        </p:txBody>
+      </p:sp>
+      <p:sp>
+        <p:nvSpPr>
+          <p:cNvPr id="20" name="Rounded Rectangle 19"/>
+          <p:cNvSpPr/>
+          <p:nvPr/>
+        </p:nvSpPr>
+        <p:spPr>
+          <a:xfrm>
+            <a:off x="4215384" y="1600200"/>
+            <a:ext cx="1700784" cy="704088"/>
+          </a:xfrm>
+          <a:prstGeom prst="roundRect">
+            <a:avLst>
+              <a:gd name="adj" fmla="val 13000"/>
+            </a:avLst>
+          </a:prstGeom>
+          <a:solidFill>
+            <a:srgbClr val="E3F6F4"/>
+          </a:solidFill>
+          <a:ln w="15240">
+            <a:solidFill>
+              <a:srgbClr val="077979"/>
+            </a:solidFill>
+          </a:ln>
+        </p:spPr>
+        <p:style>
+          <a:lnRef idx="1">
+            <a:schemeClr val="accent1"/>
+          </a:lnRef>
+          <a:fillRef idx="3">
+            <a:schemeClr val="accent1"/>
+          </a:fillRef>
+          <a:effectRef idx="2">
+            <a:schemeClr val="accent1"/>
+          </a:effectRef>
+          <a:fontRef idx="minor">
+            <a:schemeClr val="lt1"/>
+          </a:fontRef>
+        </p:style>
+        <p:txBody>
+          <a:bodyPr rtlCol="0" anchor="ctr"/>
+          <a:lstStyle/>
+          <a:p>
+            <a:pPr algn="ctr"/>
+            <a:endParaRPr/>
+          </a:p>
+        </p:txBody>
+      </p:sp>
+      <p:sp>
+        <p:nvSpPr>
+          <p:cNvPr id="21" name="TextBox 20"/>
+          <p:cNvSpPr txBox="1"/>
+          <p:nvPr/>
+        </p:nvSpPr>
+        <p:spPr>
+          <a:xfrm>
+            <a:off x="4233672" y="1636776"/>
+            <a:ext cx="1664208" cy="292608"/>
+          </a:xfrm>
+          <a:prstGeom prst="rect">
+            <a:avLst/>
+          </a:prstGeom>
+          <a:noFill/>
+        </p:spPr>
+        <p:txBody>
+          <a:bodyPr wrap="square" lIns="0" tIns="0" rIns="0" bIns="0" anchor="ctr">
+            <a:spAutoFit/>
+          </a:bodyPr>
+          <a:lstStyle/>
+          <a:p>
+            <a:pPr algn="ctr">
+              <a:spcBef>
+                <a:spcPts val="0"/>
+              </a:spcBef>
+              <a:spcAft>
+                <a:spcPts val="0"/>
+              </a:spcAft>
+              <a:defRPr sz="1200" b="1">
+                <a:solidFill>
+                  <a:srgbClr val="122E4E"/>
+                </a:solidFill>
+                <a:latin typeface="Noto Sans CJK JP"/>
+              </a:defRPr>
+            </a:pPr>
+            <a:r>
+              <a:t>HumanEvaluator</a:t>
+            </a:r>
+          </a:p>
+        </p:txBody>
+      </p:sp>
+      <p:sp>
+        <p:nvSpPr>
+          <p:cNvPr id="22" name="TextBox 21"/>
+          <p:cNvSpPr txBox="1"/>
+          <p:nvPr/>
+        </p:nvSpPr>
+        <p:spPr>
+          <a:xfrm>
+            <a:off x="4233672" y="1947672"/>
+            <a:ext cx="1664208" cy="228600"/>
+          </a:xfrm>
+          <a:prstGeom prst="rect">
+            <a:avLst/>
+          </a:prstGeom>
+          <a:noFill/>
+        </p:spPr>
+        <p:txBody>
+          <a:bodyPr wrap="square" lIns="0" tIns="0" rIns="0" bIns="0" anchor="ctr">
+            <a:spAutoFit/>
+          </a:bodyPr>
+          <a:lstStyle/>
+          <a:p>
+            <a:pPr algn="ctr">
+              <a:spcBef>
+                <a:spcPts val="0"/>
+              </a:spcBef>
+              <a:spcAft>
+                <a:spcPts val="0"/>
+              </a:spcAft>
+              <a:defRPr sz="930" b="0">
+                <a:solidFill>
+                  <a:srgbClr val="5B6E82"/>
+                </a:solidFill>
+                <a:latin typeface="Noto Sans CJK JP"/>
+              </a:defRPr>
+            </a:pPr>
+            <a:r>
+              <a:t>評価待ち・Y/N</a:t>
+            </a:r>
+          </a:p>
+        </p:txBody>
+      </p:sp>
+      <p:sp>
+        <p:nvSpPr>
+          <p:cNvPr id="24" name="Rounded Rectangle 23"/>
+          <p:cNvSpPr/>
+          <p:nvPr/>
+        </p:nvSpPr>
+        <p:spPr>
+          <a:xfrm>
+            <a:off x="6135624" y="1600200"/>
+            <a:ext cx="1700784" cy="704088"/>
+          </a:xfrm>
+          <a:prstGeom prst="roundRect">
+            <a:avLst>
+              <a:gd name="adj" fmla="val 13000"/>
+            </a:avLst>
+          </a:prstGeom>
+          <a:solidFill>
+            <a:srgbClr val="EDF5FD"/>
+          </a:solidFill>
+          <a:ln w="15240">
+            <a:solidFill>
+              <a:srgbClr val="2E6FAF"/>
+            </a:solidFill>
+          </a:ln>
+        </p:spPr>
+        <p:style>
+          <a:lnRef idx="1">
+            <a:schemeClr val="accent1"/>
+          </a:lnRef>
+          <a:fillRef idx="3">
+            <a:schemeClr val="accent1"/>
+          </a:fillRef>
+          <a:effectRef idx="2">
+            <a:schemeClr val="accent1"/>
+          </a:effectRef>
+          <a:fontRef idx="minor">
+            <a:schemeClr val="lt1"/>
+          </a:fontRef>
+        </p:style>
+        <p:txBody>
+          <a:bodyPr rtlCol="0" anchor="ctr"/>
+          <a:lstStyle/>
+          <a:p>
+            <a:pPr algn="ctr"/>
+            <a:endParaRPr/>
+          </a:p>
+        </p:txBody>
+      </p:sp>
+      <p:sp>
+        <p:nvSpPr>
+          <p:cNvPr id="25" name="TextBox 24"/>
+          <p:cNvSpPr txBox="1"/>
+          <p:nvPr/>
+        </p:nvSpPr>
+        <p:spPr>
+          <a:xfrm>
+            <a:off x="6153912" y="1636776"/>
+            <a:ext cx="1664208" cy="292608"/>
+          </a:xfrm>
+          <a:prstGeom prst="rect">
+            <a:avLst/>
+          </a:prstGeom>
+          <a:noFill/>
+        </p:spPr>
+        <p:txBody>
+          <a:bodyPr wrap="square" lIns="0" tIns="0" rIns="0" bIns="0" anchor="ctr">
+            <a:spAutoFit/>
+          </a:bodyPr>
+          <a:lstStyle/>
+          <a:p>
+            <a:pPr algn="ctr">
+              <a:spcBef>
+                <a:spcPts val="0"/>
+              </a:spcBef>
+              <a:spcAft>
+                <a:spcPts val="0"/>
+              </a:spcAft>
+              <a:defRPr sz="1200" b="1">
+                <a:solidFill>
+                  <a:srgbClr val="122E4E"/>
+                </a:solidFill>
+                <a:latin typeface="Noto Sans CJK JP"/>
+              </a:defRPr>
+            </a:pPr>
+            <a:r>
+              <a:t>利用者</a:t>
+            </a:r>
+          </a:p>
+        </p:txBody>
+      </p:sp>
+      <p:sp>
+        <p:nvSpPr>
+          <p:cNvPr id="26" name="TextBox 25"/>
+          <p:cNvSpPr txBox="1"/>
+          <p:nvPr/>
+        </p:nvSpPr>
+        <p:spPr>
+          <a:xfrm>
+            <a:off x="6153912" y="1947672"/>
+            <a:ext cx="1664208" cy="228600"/>
+          </a:xfrm>
+          <a:prstGeom prst="rect">
+            <a:avLst/>
+          </a:prstGeom>
+          <a:noFill/>
+        </p:spPr>
+        <p:txBody>
+          <a:bodyPr wrap="square" lIns="0" tIns="0" rIns="0" bIns="0" anchor="ctr">
+            <a:spAutoFit/>
+          </a:bodyPr>
+          <a:lstStyle/>
+          <a:p>
+            <a:pPr algn="ctr">
+              <a:spcBef>
+                <a:spcPts val="0"/>
+              </a:spcBef>
+              <a:spcAft>
+                <a:spcPts val="0"/>
+              </a:spcAft>
+              <a:defRPr sz="930" b="0">
+                <a:solidFill>
+                  <a:srgbClr val="5B6E82"/>
+                </a:solidFill>
+                <a:latin typeface="Noto Sans CJK JP"/>
+              </a:defRPr>
+            </a:pPr>
+            <a:r>
+              <a:t>Y / N キー入力</a:t>
+            </a:r>
+          </a:p>
+        </p:txBody>
+      </p:sp>
+      <p:sp>
+        <p:nvSpPr>
+          <p:cNvPr id="28" name="Rounded Rectangle 27"/>
+          <p:cNvSpPr/>
+          <p:nvPr/>
+        </p:nvSpPr>
+        <p:spPr>
+          <a:xfrm>
+            <a:off x="8046720" y="1600200"/>
+            <a:ext cx="1700784" cy="704088"/>
+          </a:xfrm>
+          <a:prstGeom prst="roundRect">
+            <a:avLst>
+              <a:gd name="adj" fmla="val 13000"/>
+            </a:avLst>
+          </a:prstGeom>
+          <a:solidFill>
+            <a:srgbClr val="E3F6F4"/>
+          </a:solidFill>
+          <a:ln w="15240">
+            <a:solidFill>
+              <a:srgbClr val="077979"/>
+            </a:solidFill>
+          </a:ln>
+        </p:spPr>
+        <p:style>
+          <a:lnRef idx="1">
+            <a:schemeClr val="accent1"/>
+          </a:lnRef>
+          <a:fillRef idx="3">
+            <a:schemeClr val="accent1"/>
+          </a:fillRef>
+          <a:effectRef idx="2">
+            <a:schemeClr val="accent1"/>
+          </a:effectRef>
+          <a:fontRef idx="minor">
+            <a:schemeClr val="lt1"/>
+          </a:fontRef>
+        </p:style>
+        <p:txBody>
+          <a:bodyPr rtlCol="0" anchor="ctr"/>
+          <a:lstStyle/>
+          <a:p>
+            <a:pPr algn="ctr"/>
+            <a:endParaRPr/>
+          </a:p>
+        </p:txBody>
+      </p:sp>
+      <p:sp>
+        <p:nvSpPr>
+          <p:cNvPr id="29" name="TextBox 28"/>
+          <p:cNvSpPr txBox="1"/>
+          <p:nvPr/>
+        </p:nvSpPr>
+        <p:spPr>
+          <a:xfrm>
+            <a:off x="8065008" y="1636776"/>
+            <a:ext cx="1664208" cy="292608"/>
+          </a:xfrm>
+          <a:prstGeom prst="rect">
+            <a:avLst/>
+          </a:prstGeom>
+          <a:noFill/>
+        </p:spPr>
+        <p:txBody>
+          <a:bodyPr wrap="square" lIns="0" tIns="0" rIns="0" bIns="0" anchor="ctr">
+            <a:spAutoFit/>
+          </a:bodyPr>
+          <a:lstStyle/>
+          <a:p>
+            <a:pPr algn="ctr">
+              <a:spcBef>
+                <a:spcPts val="0"/>
+              </a:spcBef>
+              <a:spcAft>
+                <a:spcPts val="0"/>
+              </a:spcAft>
+              <a:defRPr sz="1200" b="1">
+                <a:solidFill>
+                  <a:srgbClr val="122E4E"/>
+                </a:solidFill>
+                <a:latin typeface="Noto Sans CJK JP"/>
+              </a:defRPr>
+            </a:pPr>
+            <a:r>
+              <a:t>ExperienceLogger</a:t>
+            </a:r>
+          </a:p>
+        </p:txBody>
+      </p:sp>
+      <p:sp>
+        <p:nvSpPr>
+          <p:cNvPr id="30" name="TextBox 29"/>
+          <p:cNvSpPr txBox="1"/>
+          <p:nvPr/>
+        </p:nvSpPr>
+        <p:spPr>
+          <a:xfrm>
+            <a:off x="8065008" y="1947672"/>
+            <a:ext cx="1664208" cy="228600"/>
+          </a:xfrm>
+          <a:prstGeom prst="rect">
+            <a:avLst/>
+          </a:prstGeom>
+          <a:noFill/>
+        </p:spPr>
+        <p:txBody>
+          <a:bodyPr wrap="square" lIns="0" tIns="0" rIns="0" bIns="0" anchor="ctr">
+            <a:spAutoFit/>
+          </a:bodyPr>
+          <a:lstStyle/>
+          <a:p>
+            <a:pPr algn="ctr">
+              <a:spcBef>
+                <a:spcPts val="0"/>
+              </a:spcBef>
+              <a:spcAft>
+                <a:spcPts val="0"/>
+              </a:spcAft>
+              <a:defRPr sz="930" b="0">
+                <a:solidFill>
+                  <a:srgbClr val="5B6E82"/>
+                </a:solidFill>
+                <a:latin typeface="Noto Sans CJK JP"/>
+              </a:defRPr>
+            </a:pPr>
+            <a:r>
+              <a:t>JSONLへの追記</a:t>
+            </a:r>
+          </a:p>
+        </p:txBody>
+      </p:sp>
+      <p:sp>
+        <p:nvSpPr>
+          <p:cNvPr id="32" name="Rounded Rectangle 31"/>
+          <p:cNvSpPr/>
+          <p:nvPr/>
+        </p:nvSpPr>
+        <p:spPr>
+          <a:xfrm>
+            <a:off x="9921240" y="1600200"/>
+            <a:ext cx="1700784" cy="704088"/>
+          </a:xfrm>
+          <a:prstGeom prst="roundRect">
+            <a:avLst>
+              <a:gd name="adj" fmla="val 13000"/>
+            </a:avLst>
+          </a:prstGeom>
+          <a:solidFill>
+            <a:srgbClr val="FFF7E1"/>
+          </a:solidFill>
+          <a:ln w="15240">
+            <a:solidFill>
+              <a:srgbClr val="B5751E"/>
+            </a:solidFill>
+          </a:ln>
+        </p:spPr>
+        <p:style>
+          <a:lnRef idx="1">
+            <a:schemeClr val="accent1"/>
+          </a:lnRef>
+          <a:fillRef idx="3">
+            <a:schemeClr val="accent1"/>
+          </a:fillRef>
+          <a:effectRef idx="2">
+            <a:schemeClr val="accent1"/>
+          </a:effectRef>
+          <a:fontRef idx="minor">
+            <a:schemeClr val="lt1"/>
+          </a:fontRef>
+        </p:style>
+        <p:txBody>
+          <a:bodyPr rtlCol="0" anchor="ctr"/>
+          <a:lstStyle/>
+          <a:p>
+            <a:pPr algn="ctr"/>
+            <a:endParaRPr/>
+          </a:p>
+        </p:txBody>
+      </p:sp>
+      <p:sp>
+        <p:nvSpPr>
+          <p:cNvPr id="33" name="TextBox 32"/>
+          <p:cNvSpPr txBox="1"/>
+          <p:nvPr/>
+        </p:nvSpPr>
+        <p:spPr>
+          <a:xfrm>
+            <a:off x="9939528" y="1636776"/>
+            <a:ext cx="1664208" cy="292608"/>
+          </a:xfrm>
+          <a:prstGeom prst="rect">
+            <a:avLst/>
+          </a:prstGeom>
+          <a:noFill/>
+        </p:spPr>
+        <p:txBody>
+          <a:bodyPr wrap="square" lIns="0" tIns="0" rIns="0" bIns="0" anchor="ctr">
+            <a:spAutoFit/>
+          </a:bodyPr>
+          <a:lstStyle/>
+          <a:p>
+            <a:pPr algn="ctr">
+              <a:spcBef>
+                <a:spcPts val="0"/>
+              </a:spcBef>
+              <a:spcAft>
+                <a:spcPts val="0"/>
+              </a:spcAft>
+              <a:defRPr sz="1200" b="1">
+                <a:solidFill>
+                  <a:srgbClr val="122E4E"/>
+                </a:solidFill>
+                <a:latin typeface="Noto Sans CJK JP"/>
+              </a:defRPr>
+            </a:pPr>
+            <a:r>
+              <a:t>experience.jsonl</a:t>
+            </a:r>
+          </a:p>
+        </p:txBody>
+      </p:sp>
+      <p:sp>
+        <p:nvSpPr>
+          <p:cNvPr id="34" name="TextBox 33"/>
+          <p:cNvSpPr txBox="1"/>
+          <p:nvPr/>
+        </p:nvSpPr>
+        <p:spPr>
+          <a:xfrm>
+            <a:off x="9939528" y="1947672"/>
+            <a:ext cx="1664208" cy="228600"/>
+          </a:xfrm>
+          <a:prstGeom prst="rect">
+            <a:avLst/>
+          </a:prstGeom>
+          <a:noFill/>
+        </p:spPr>
+        <p:txBody>
+          <a:bodyPr wrap="square" lIns="0" tIns="0" rIns="0" bIns="0" anchor="ctr">
+            <a:spAutoFit/>
+          </a:bodyPr>
+          <a:lstStyle/>
+          <a:p>
+            <a:pPr algn="ctr">
+              <a:spcBef>
+                <a:spcPts val="0"/>
+              </a:spcBef>
+              <a:spcAft>
+                <a:spcPts val="0"/>
+              </a:spcAft>
+              <a:defRPr sz="930" b="0">
+                <a:solidFill>
+                  <a:srgbClr val="5B6E82"/>
+                </a:solidFill>
+                <a:latin typeface="Noto Sans CJK JP"/>
+              </a:defRPr>
+            </a:pPr>
+            <a:r>
+              <a:t>Portable / tmp</a:t>
+            </a:r>
+          </a:p>
+        </p:txBody>
+      </p:sp>
+      <p:sp>
+        <p:nvSpPr>
+          <p:cNvPr id="36" name="Rectangle 35"/>
+          <p:cNvSpPr/>
+          <p:nvPr/>
+        </p:nvSpPr>
+        <p:spPr>
+          <a:xfrm>
+            <a:off x="1185062" y="2651760"/>
+            <a:ext cx="80467" cy="310896"/>
+          </a:xfrm>
+          <a:prstGeom prst="rect">
+            <a:avLst/>
+          </a:prstGeom>
+          <a:solidFill>
+            <a:srgbClr val="E3F6F4"/>
+          </a:solidFill>
+          <a:ln w="10160">
+            <a:solidFill>
+              <a:srgbClr val="077979"/>
+            </a:solidFill>
+          </a:ln>
+        </p:spPr>
+        <p:style>
+          <a:lnRef idx="1">
+            <a:schemeClr val="accent1"/>
+          </a:lnRef>
+          <a:fillRef idx="3">
+            <a:schemeClr val="accent1"/>
+          </a:fillRef>
+          <a:effectRef idx="2">
+            <a:schemeClr val="accent1"/>
+          </a:effectRef>
+          <a:fontRef idx="minor">
+            <a:schemeClr val="lt1"/>
+          </a:fontRef>
+        </p:style>
+        <p:txBody>
+          <a:bodyPr rtlCol="0" anchor="ctr"/>
+          <a:lstStyle/>
+          <a:p>
+            <a:pPr algn="ctr"/>
+            <a:endParaRPr/>
+          </a:p>
+        </p:txBody>
+      </p:sp>
+      <p:sp>
+        <p:nvSpPr>
+          <p:cNvPr id="37" name="Rectangle 36"/>
+          <p:cNvSpPr/>
+          <p:nvPr/>
+        </p:nvSpPr>
+        <p:spPr>
+          <a:xfrm>
+            <a:off x="3096158" y="2651760"/>
+            <a:ext cx="80467" cy="896112"/>
+          </a:xfrm>
+          <a:prstGeom prst="rect">
+            <a:avLst/>
+          </a:prstGeom>
+          <a:solidFill>
+            <a:srgbClr val="E3F6F4"/>
+          </a:solidFill>
+          <a:ln w="10160">
+            <a:solidFill>
+              <a:srgbClr val="077979"/>
+            </a:solidFill>
+          </a:ln>
+        </p:spPr>
+        <p:style>
+          <a:lnRef idx="1">
+            <a:schemeClr val="accent1"/>
+          </a:lnRef>
+          <a:fillRef idx="3">
+            <a:schemeClr val="accent1"/>
+          </a:fillRef>
+          <a:effectRef idx="2">
+            <a:schemeClr val="accent1"/>
+          </a:effectRef>
+          <a:fontRef idx="minor">
+            <a:schemeClr val="lt1"/>
+          </a:fontRef>
+        </p:style>
+        <p:txBody>
+          <a:bodyPr rtlCol="0" anchor="ctr"/>
+          <a:lstStyle/>
+          <a:p>
+            <a:pPr algn="ctr"/>
+            <a:endParaRPr/>
+          </a:p>
+        </p:txBody>
+      </p:sp>
+      <p:sp>
+        <p:nvSpPr>
+          <p:cNvPr id="38" name="Rectangle 37"/>
+          <p:cNvSpPr/>
+          <p:nvPr/>
+        </p:nvSpPr>
+        <p:spPr>
+          <a:xfrm>
+            <a:off x="5025542" y="3529584"/>
+            <a:ext cx="80467" cy="1371600"/>
+          </a:xfrm>
+          <a:prstGeom prst="rect">
+            <a:avLst/>
+          </a:prstGeom>
+          <a:solidFill>
+            <a:srgbClr val="E3F6F4"/>
+          </a:solidFill>
+          <a:ln w="10160">
+            <a:solidFill>
+              <a:srgbClr val="077979"/>
+            </a:solidFill>
+          </a:ln>
+        </p:spPr>
+        <p:style>
+          <a:lnRef idx="1">
+            <a:schemeClr val="accent1"/>
+          </a:lnRef>
+          <a:fillRef idx="3">
+            <a:schemeClr val="accent1"/>
+          </a:fillRef>
+          <a:effectRef idx="2">
+            <a:schemeClr val="accent1"/>
+          </a:effectRef>
+          <a:fontRef idx="minor">
+            <a:schemeClr val="lt1"/>
+          </a:fontRef>
+        </p:style>
+        <p:txBody>
+          <a:bodyPr rtlCol="0" anchor="ctr"/>
+          <a:lstStyle/>
+          <a:p>
+            <a:pPr algn="ctr"/>
+            <a:endParaRPr/>
+          </a:p>
+        </p:txBody>
+      </p:sp>
+      <p:sp>
+        <p:nvSpPr>
+          <p:cNvPr id="39" name="Rectangle 38"/>
+          <p:cNvSpPr/>
+          <p:nvPr/>
+        </p:nvSpPr>
+        <p:spPr>
+          <a:xfrm>
+            <a:off x="6945782" y="4078224"/>
+            <a:ext cx="80467" cy="722376"/>
+          </a:xfrm>
+          <a:prstGeom prst="rect">
+            <a:avLst/>
+          </a:prstGeom>
+          <a:solidFill>
+            <a:srgbClr val="EDF5FD"/>
+          </a:solidFill>
+          <a:ln w="10160">
+            <a:solidFill>
+              <a:srgbClr val="2E6FAF"/>
+            </a:solidFill>
+          </a:ln>
+        </p:spPr>
+        <p:style>
+          <a:lnRef idx="1">
+            <a:schemeClr val="accent1"/>
+          </a:lnRef>
+          <a:fillRef idx="3">
+            <a:schemeClr val="accent1"/>
+          </a:fillRef>
+          <a:effectRef idx="2">
+            <a:schemeClr val="accent1"/>
+          </a:effectRef>
+          <a:fontRef idx="minor">
+            <a:schemeClr val="lt1"/>
+          </a:fontRef>
+        </p:style>
+        <p:txBody>
+          <a:bodyPr rtlCol="0" anchor="ctr"/>
+          <a:lstStyle/>
+          <a:p>
+            <a:pPr algn="ctr"/>
+            <a:endParaRPr/>
+          </a:p>
+        </p:txBody>
+      </p:sp>
+      <p:sp>
+        <p:nvSpPr>
+          <p:cNvPr id="40" name="Rectangle 39"/>
+          <p:cNvSpPr/>
+          <p:nvPr/>
+        </p:nvSpPr>
+        <p:spPr>
+          <a:xfrm>
+            <a:off x="8856878" y="5010912"/>
+            <a:ext cx="80467" cy="530352"/>
+          </a:xfrm>
+          <a:prstGeom prst="rect">
+            <a:avLst/>
+          </a:prstGeom>
+          <a:solidFill>
+            <a:srgbClr val="E3F6F4"/>
+          </a:solidFill>
+          <a:ln w="10160">
+            <a:solidFill>
+              <a:srgbClr val="077979"/>
+            </a:solidFill>
+          </a:ln>
+        </p:spPr>
+        <p:style>
+          <a:lnRef idx="1">
+            <a:schemeClr val="accent1"/>
+          </a:lnRef>
+          <a:fillRef idx="3">
+            <a:schemeClr val="accent1"/>
+          </a:fillRef>
+          <a:effectRef idx="2">
+            <a:schemeClr val="accent1"/>
+          </a:effectRef>
+          <a:fontRef idx="minor">
+            <a:schemeClr val="lt1"/>
+          </a:fontRef>
+        </p:style>
+        <p:txBody>
+          <a:bodyPr rtlCol="0" anchor="ctr"/>
+          <a:lstStyle/>
+          <a:p>
+            <a:pPr algn="ctr"/>
+            <a:endParaRPr/>
+          </a:p>
+        </p:txBody>
+      </p:sp>
+      <p:sp>
+        <p:nvSpPr>
+          <p:cNvPr id="41" name="Rectangle 40"/>
+          <p:cNvSpPr/>
+          <p:nvPr/>
+        </p:nvSpPr>
+        <p:spPr>
+          <a:xfrm>
+            <a:off x="10731398" y="5468112"/>
+            <a:ext cx="80467" cy="237744"/>
+          </a:xfrm>
+          <a:prstGeom prst="rect">
+            <a:avLst/>
+          </a:prstGeom>
+          <a:solidFill>
+            <a:srgbClr val="EDF5FD"/>
+          </a:solidFill>
+          <a:ln w="10160">
+            <a:solidFill>
+              <a:srgbClr val="B5751E"/>
+            </a:solidFill>
+          </a:ln>
+        </p:spPr>
+        <p:style>
+          <a:lnRef idx="1">
+            <a:schemeClr val="accent1"/>
+          </a:lnRef>
+          <a:fillRef idx="3">
+            <a:schemeClr val="accent1"/>
+          </a:fillRef>
+          <a:effectRef idx="2">
+            <a:schemeClr val="accent1"/>
+          </a:effectRef>
+          <a:fontRef idx="minor">
+            <a:schemeClr val="lt1"/>
+          </a:fontRef>
+        </p:style>
+        <p:txBody>
+          <a:bodyPr rtlCol="0" anchor="ctr"/>
+          <a:lstStyle/>
+          <a:p>
+            <a:pPr algn="ctr"/>
+            <a:endParaRPr/>
+          </a:p>
+        </p:txBody>
+      </p:sp>
+      <p:sp>
+        <p:nvSpPr>
+          <p:cNvPr id="42" name="Rounded Rectangle 41"/>
+          <p:cNvSpPr/>
+          <p:nvPr/>
+        </p:nvSpPr>
+        <p:spPr>
+          <a:xfrm>
+            <a:off x="667512" y="2450592"/>
+            <a:ext cx="11082528" cy="932688"/>
+          </a:xfrm>
+          <a:prstGeom prst="roundRect">
+            <a:avLst>
+              <a:gd name="adj" fmla="val 13000"/>
+            </a:avLst>
+          </a:prstGeom>
+          <a:solidFill>
+            <a:srgbClr val="F8FBFE"/>
+          </a:solidFill>
+          <a:ln>
+            <a:noFill/>
+          </a:ln>
+        </p:spPr>
+        <p:style>
+          <a:lnRef idx="1">
+            <a:schemeClr val="accent1"/>
+          </a:lnRef>
+          <a:fillRef idx="3">
+            <a:schemeClr val="accent1"/>
+          </a:fillRef>
+          <a:effectRef idx="2">
+            <a:schemeClr val="accent1"/>
+          </a:effectRef>
+          <a:fontRef idx="minor">
+            <a:schemeClr val="lt1"/>
+          </a:fontRef>
+        </p:style>
+        <p:txBody>
+          <a:bodyPr rtlCol="0" anchor="ctr"/>
+          <a:lstStyle/>
+          <a:p>
+            <a:pPr algn="ctr"/>
+            <a:endParaRPr/>
+          </a:p>
+        </p:txBody>
+      </p:sp>
+      <p:sp>
+        <p:nvSpPr>
+          <p:cNvPr id="43" name="Rounded Rectangle 42"/>
+          <p:cNvSpPr/>
+          <p:nvPr/>
+        </p:nvSpPr>
+        <p:spPr>
+          <a:xfrm>
+            <a:off x="667512" y="3474720"/>
+            <a:ext cx="11082528" cy="1344168"/>
+          </a:xfrm>
+          <a:prstGeom prst="roundRect">
+            <a:avLst>
+              <a:gd name="adj" fmla="val 13000"/>
+            </a:avLst>
+          </a:prstGeom>
+          <a:solidFill>
+            <a:srgbClr val="F7FCFA"/>
+          </a:solidFill>
+          <a:ln>
+            <a:noFill/>
+          </a:ln>
+        </p:spPr>
+        <p:style>
+          <a:lnRef idx="1">
+            <a:schemeClr val="accent1"/>
+          </a:lnRef>
+          <a:fillRef idx="3">
+            <a:schemeClr val="accent1"/>
+          </a:fillRef>
+          <a:effectRef idx="2">
+            <a:schemeClr val="accent1"/>
+          </a:effectRef>
+          <a:fontRef idx="minor">
+            <a:schemeClr val="lt1"/>
+          </a:fontRef>
+        </p:style>
+        <p:txBody>
+          <a:bodyPr rtlCol="0" anchor="ctr"/>
+          <a:lstStyle/>
+          <a:p>
+            <a:pPr algn="ctr"/>
+            <a:endParaRPr/>
+          </a:p>
+        </p:txBody>
+      </p:sp>
+      <p:sp>
+        <p:nvSpPr>
+          <p:cNvPr id="44" name="Rounded Rectangle 43"/>
+          <p:cNvSpPr/>
+          <p:nvPr/>
+        </p:nvSpPr>
+        <p:spPr>
+          <a:xfrm>
+            <a:off x="667512" y="4892040"/>
+            <a:ext cx="11082528" cy="813816"/>
+          </a:xfrm>
+          <a:prstGeom prst="roundRect">
+            <a:avLst>
+              <a:gd name="adj" fmla="val 13000"/>
+            </a:avLst>
+          </a:prstGeom>
+          <a:solidFill>
+            <a:srgbClr val="FBFCFD"/>
+          </a:solidFill>
+          <a:ln>
+            <a:noFill/>
+          </a:ln>
+        </p:spPr>
+        <p:style>
+          <a:lnRef idx="1">
+            <a:schemeClr val="accent1"/>
+          </a:lnRef>
+          <a:fillRef idx="3">
+            <a:schemeClr val="accent1"/>
+          </a:fillRef>
+          <a:effectRef idx="2">
+            <a:schemeClr val="accent1"/>
+          </a:effectRef>
+          <a:fontRef idx="minor">
+            <a:schemeClr val="lt1"/>
+          </a:fontRef>
+        </p:style>
+        <p:txBody>
+          <a:bodyPr rtlCol="0" anchor="ctr"/>
+          <a:lstStyle/>
+          <a:p>
+            <a:pPr algn="ctr"/>
+            <a:endParaRPr/>
+          </a:p>
+        </p:txBody>
+      </p:sp>
+      <p:sp>
+        <p:nvSpPr>
+          <p:cNvPr id="45" name="Oval 44"/>
+          <p:cNvSpPr/>
+          <p:nvPr/>
+        </p:nvSpPr>
+        <p:spPr>
+          <a:xfrm>
+            <a:off x="338328" y="2569464"/>
+            <a:ext cx="246888" cy="246888"/>
+          </a:xfrm>
+          <a:prstGeom prst="ellipse">
+            <a:avLst/>
+          </a:prstGeom>
+          <a:solidFill>
+            <a:srgbClr val="2E6FAF"/>
+          </a:solidFill>
+          <a:ln>
+            <a:noFill/>
+          </a:ln>
+        </p:spPr>
+        <p:style>
+          <a:lnRef idx="1">
+            <a:schemeClr val="accent1"/>
+          </a:lnRef>
+          <a:fillRef idx="3">
+            <a:schemeClr val="accent1"/>
+          </a:fillRef>
+          <a:effectRef idx="2">
+            <a:schemeClr val="accent1"/>
+          </a:effectRef>
+          <a:fontRef idx="minor">
+            <a:schemeClr val="lt1"/>
+          </a:fontRef>
+        </p:style>
+        <p:txBody>
+          <a:bodyPr rtlCol="0" anchor="ctr"/>
+          <a:lstStyle/>
+          <a:p>
+            <a:pPr algn="ctr"/>
+            <a:endParaRPr/>
+          </a:p>
+        </p:txBody>
+      </p:sp>
+      <p:sp>
+        <p:nvSpPr>
+          <p:cNvPr id="46" name="TextBox 45"/>
+          <p:cNvSpPr txBox="1"/>
+          <p:nvPr/>
+        </p:nvSpPr>
+        <p:spPr>
+          <a:xfrm>
+            <a:off x="343814" y="2574036"/>
+            <a:ext cx="237744" cy="228600"/>
+          </a:xfrm>
+          <a:prstGeom prst="rect">
+            <a:avLst/>
+          </a:prstGeom>
+          <a:noFill/>
+        </p:spPr>
+        <p:txBody>
+          <a:bodyPr wrap="square" lIns="0" tIns="0" rIns="0" bIns="0" anchor="ctr">
+            <a:spAutoFit/>
+          </a:bodyPr>
+          <a:lstStyle/>
+          <a:p>
+            <a:pPr algn="ctr">
+              <a:spcBef>
+                <a:spcPts val="0"/>
+              </a:spcBef>
+              <a:spcAft>
+                <a:spcPts val="0"/>
+              </a:spcAft>
+              <a:defRPr sz="1100" b="1">
+                <a:solidFill>
+                  <a:srgbClr val="FFFFFF"/>
+                </a:solidFill>
+                <a:latin typeface="Noto Sans CJK JP"/>
+              </a:defRPr>
+            </a:pPr>
+            <a:r>
+              <a:t>10</a:t>
+            </a:r>
+          </a:p>
+        </p:txBody>
+      </p:sp>
+      <p:cxnSp>
+        <p:nvCxnSpPr>
+          <p:cNvPr id="47" name="Connector 46"/>
+          <p:cNvCxnSpPr/>
+          <p:nvPr/>
+        </p:nvCxnSpPr>
+        <p:spPr>
+          <a:xfrm>
+            <a:off x="1225296" y="2724912"/>
+            <a:ext cx="1911096" cy="0"/>
+          </a:xfrm>
+          <a:prstGeom prst="line">
+            <a:avLst/>
+          </a:prstGeom>
+          <a:ln w="17780">
+            <a:solidFill>
+              <a:srgbClr val="077979"/>
+            </a:solidFill>
+          </a:ln>
+        </p:spPr>
+        <p:style>
+          <a:lnRef idx="2">
+            <a:schemeClr val="accent1"/>
+          </a:lnRef>
+          <a:fillRef idx="0">
+            <a:schemeClr val="accent1"/>
+          </a:fillRef>
+          <a:effectRef idx="1">
+            <a:schemeClr val="accent1"/>
+          </a:effectRef>
+          <a:fontRef idx="minor">
+            <a:schemeClr val="tx1"/>
+          </a:fontRef>
+        </p:style>
+      </p:cxnSp>
+      <p:sp>
+        <p:nvSpPr>
+          <p:cNvPr id="48" name="Isosceles Triangle 47"/>
+          <p:cNvSpPr/>
+          <p:nvPr/>
+        </p:nvSpPr>
+        <p:spPr>
+          <a:xfrm rot="5400000">
+            <a:off x="3093415" y="2682849"/>
+            <a:ext cx="86868" cy="86868"/>
+          </a:xfrm>
+          <a:prstGeom prst="triangle">
+            <a:avLst/>
+          </a:prstGeom>
+          <a:solidFill>
+            <a:srgbClr val="077979"/>
+          </a:solidFill>
+          <a:ln>
+            <a:noFill/>
+          </a:ln>
+        </p:spPr>
+        <p:style>
+          <a:lnRef idx="1">
+            <a:schemeClr val="accent1"/>
+          </a:lnRef>
+          <a:fillRef idx="3">
+            <a:schemeClr val="accent1"/>
+          </a:fillRef>
+          <a:effectRef idx="2">
+            <a:schemeClr val="accent1"/>
+          </a:effectRef>
+          <a:fontRef idx="minor">
+            <a:schemeClr val="lt1"/>
+          </a:fontRef>
+        </p:style>
+        <p:txBody>
+          <a:bodyPr rtlCol="0" anchor="ctr"/>
+          <a:lstStyle/>
+          <a:p>
+            <a:pPr algn="ctr"/>
+            <a:endParaRPr/>
+          </a:p>
+        </p:txBody>
+      </p:sp>
+      <p:sp>
+        <p:nvSpPr>
+          <p:cNvPr id="49" name="TextBox 48"/>
+          <p:cNvSpPr txBox="1"/>
+          <p:nvPr/>
+        </p:nvSpPr>
+        <p:spPr>
+          <a:xfrm>
+            <a:off x="1298448" y="2496312"/>
+            <a:ext cx="1828800" cy="201168"/>
+          </a:xfrm>
+          <a:prstGeom prst="rect">
+            <a:avLst/>
+          </a:prstGeom>
+          <a:noFill/>
+        </p:spPr>
+        <p:txBody>
+          <a:bodyPr wrap="square" lIns="0" tIns="0" rIns="0" bIns="0" anchor="ctr">
+            <a:spAutoFit/>
+          </a:bodyPr>
+          <a:lstStyle/>
+          <a:p>
+            <a:pPr algn="ctr">
+              <a:spcBef>
+                <a:spcPts val="0"/>
+              </a:spcBef>
+              <a:spcAft>
+                <a:spcPts val="0"/>
+              </a:spcAft>
+              <a:defRPr sz="1070" b="1">
+                <a:solidFill>
+                  <a:srgbClr val="1E354F"/>
+                </a:solidFill>
+                <a:latin typeface="Noto Sans CJK JP"/>
+              </a:defRPr>
+            </a:pPr>
+            <a:r>
+              <a:t>⑩ VerifyPosition(request)</a:t>
+            </a:r>
+          </a:p>
+        </p:txBody>
+      </p:sp>
+      <p:cxnSp>
+        <p:nvCxnSpPr>
+          <p:cNvPr id="50" name="Connector 49"/>
+          <p:cNvCxnSpPr/>
+          <p:nvPr/>
+        </p:nvCxnSpPr>
+        <p:spPr>
+          <a:xfrm>
+            <a:off x="3136392" y="3054096"/>
+            <a:ext cx="484632" cy="0"/>
+          </a:xfrm>
+          <a:prstGeom prst="line">
+            <a:avLst/>
+          </a:prstGeom>
+          <a:ln w="17780">
+            <a:solidFill>
+              <a:srgbClr val="077979"/>
+            </a:solidFill>
+          </a:ln>
+        </p:spPr>
+        <p:style>
+          <a:lnRef idx="2">
+            <a:schemeClr val="accent1"/>
+          </a:lnRef>
+          <a:fillRef idx="0">
+            <a:schemeClr val="accent1"/>
+          </a:fillRef>
+          <a:effectRef idx="1">
+            <a:schemeClr val="accent1"/>
+          </a:effectRef>
+          <a:fontRef idx="minor">
+            <a:schemeClr val="tx1"/>
+          </a:fontRef>
+        </p:style>
+      </p:cxnSp>
+      <p:cxnSp>
+        <p:nvCxnSpPr>
+          <p:cNvPr id="51" name="Connector 50"/>
+          <p:cNvCxnSpPr/>
+          <p:nvPr/>
+        </p:nvCxnSpPr>
+        <p:spPr>
+          <a:xfrm>
+            <a:off x="3621024" y="3054096"/>
+            <a:ext cx="0" cy="228600"/>
+          </a:xfrm>
+          <a:prstGeom prst="line">
+            <a:avLst/>
+          </a:prstGeom>
+          <a:ln w="17780">
+            <a:solidFill>
+              <a:srgbClr val="077979"/>
+            </a:solidFill>
+          </a:ln>
+        </p:spPr>
+        <p:style>
+          <a:lnRef idx="2">
+            <a:schemeClr val="accent1"/>
+          </a:lnRef>
+          <a:fillRef idx="0">
+            <a:schemeClr val="accent1"/>
+          </a:fillRef>
+          <a:effectRef idx="1">
+            <a:schemeClr val="accent1"/>
+          </a:effectRef>
+          <a:fontRef idx="minor">
+            <a:schemeClr val="tx1"/>
+          </a:fontRef>
+        </p:style>
+      </p:cxnSp>
+      <p:cxnSp>
+        <p:nvCxnSpPr>
+          <p:cNvPr id="52" name="Connector 51"/>
+          <p:cNvCxnSpPr>
+            <a:cxnSpLocks/>
+          </p:cNvCxnSpPr>
+          <p:nvPr/>
+        </p:nvCxnSpPr>
+        <p:spPr>
+          <a:xfrm flipV="1">
+            <a:off x="3118104" y="3282696"/>
+            <a:ext cx="502920" cy="5184"/>
+          </a:xfrm>
+          <a:prstGeom prst="line">
+            <a:avLst/>
+          </a:prstGeom>
+          <a:ln w="17780">
+            <a:solidFill>
+              <a:srgbClr val="077979"/>
+            </a:solidFill>
+            <a:headEnd type="triangle"/>
+          </a:ln>
+        </p:spPr>
+        <p:style>
+          <a:lnRef idx="2">
+            <a:schemeClr val="accent1"/>
+          </a:lnRef>
+          <a:fillRef idx="0">
+            <a:schemeClr val="accent1"/>
+          </a:fillRef>
+          <a:effectRef idx="1">
+            <a:schemeClr val="accent1"/>
+          </a:effectRef>
+          <a:fontRef idx="minor">
+            <a:schemeClr val="tx1"/>
+          </a:fontRef>
+        </p:style>
+      </p:cxnSp>
+      <p:sp>
+        <p:nvSpPr>
+          <p:cNvPr id="54" name="TextBox 53"/>
+          <p:cNvSpPr txBox="1"/>
+          <p:nvPr/>
+        </p:nvSpPr>
+        <p:spPr>
+          <a:xfrm>
+            <a:off x="3297935" y="2816352"/>
+            <a:ext cx="4526280" cy="246888"/>
+          </a:xfrm>
+          <a:prstGeom prst="rect">
+            <a:avLst/>
+          </a:prstGeom>
+          <a:noFill/>
+        </p:spPr>
+        <p:txBody>
+          <a:bodyPr wrap="square" lIns="0" tIns="0" rIns="0" bIns="0" anchor="ctr">
+            <a:spAutoFit/>
+          </a:bodyPr>
+          <a:lstStyle/>
+          <a:p>
+            <a:pPr algn="l">
+              <a:spcBef>
+                <a:spcPts val="0"/>
+              </a:spcBef>
+              <a:spcAft>
+                <a:spcPts val="0"/>
+              </a:spcAft>
+              <a:defRPr sz="980" b="0">
+                <a:solidFill>
+                  <a:srgbClr val="1E354F"/>
+                </a:solidFill>
+                <a:latin typeface="Noto Sans CJK JP"/>
+              </a:defRPr>
+            </a:pPr>
+            <a:r>
+              <a:rPr dirty="0" err="1"/>
+              <a:t>期待位置</a:t>
+            </a:r>
+            <a:r>
+              <a:rPr dirty="0"/>
+              <a:t> = Human_1位置 + 方向×1.0   /   </a:t>
+            </a:r>
+            <a:r>
+              <a:rPr dirty="0" err="1"/>
+              <a:t>誤差</a:t>
+            </a:r>
+            <a:r>
+              <a:rPr dirty="0"/>
+              <a:t> = 0</a:t>
+            </a:r>
+          </a:p>
+        </p:txBody>
+      </p:sp>
+      <p:sp>
+        <p:nvSpPr>
+          <p:cNvPr id="55" name="TextBox 54"/>
+          <p:cNvSpPr txBox="1"/>
+          <p:nvPr/>
+        </p:nvSpPr>
+        <p:spPr>
+          <a:xfrm>
+            <a:off x="3685627" y="3176625"/>
+            <a:ext cx="2487168" cy="201168"/>
+          </a:xfrm>
+          <a:prstGeom prst="rect">
+            <a:avLst/>
+          </a:prstGeom>
+          <a:noFill/>
+        </p:spPr>
+        <p:txBody>
+          <a:bodyPr wrap="square" lIns="0" tIns="0" rIns="0" bIns="0" anchor="ctr">
+            <a:spAutoFit/>
+          </a:bodyPr>
+          <a:lstStyle/>
+          <a:p>
+            <a:pPr algn="l">
+              <a:spcBef>
+                <a:spcPts val="0"/>
+              </a:spcBef>
+              <a:spcAft>
+                <a:spcPts val="0"/>
+              </a:spcAft>
+              <a:defRPr sz="980" b="1">
+                <a:solidFill>
+                  <a:srgbClr val="077979"/>
+                </a:solidFill>
+                <a:latin typeface="Noto Sans CJK JP"/>
+              </a:defRPr>
+            </a:pPr>
+            <a:r>
+              <a:rPr dirty="0" err="1"/>
+              <a:t>PASS：誤差</a:t>
+            </a:r>
+            <a:r>
+              <a:rPr dirty="0"/>
+              <a:t> ≤ 0.05</a:t>
+            </a:r>
+          </a:p>
+        </p:txBody>
+      </p:sp>
+      <p:sp>
+        <p:nvSpPr>
+          <p:cNvPr id="56" name="Oval 55"/>
+          <p:cNvSpPr/>
+          <p:nvPr/>
+        </p:nvSpPr>
+        <p:spPr>
+          <a:xfrm>
+            <a:off x="338328" y="3557015"/>
+            <a:ext cx="246888" cy="246888"/>
+          </a:xfrm>
+          <a:prstGeom prst="ellipse">
+            <a:avLst/>
+          </a:prstGeom>
+          <a:solidFill>
+            <a:srgbClr val="077979"/>
+          </a:solidFill>
+          <a:ln>
+            <a:noFill/>
+          </a:ln>
+        </p:spPr>
+        <p:style>
+          <a:lnRef idx="1">
+            <a:schemeClr val="accent1"/>
+          </a:lnRef>
+          <a:fillRef idx="3">
+            <a:schemeClr val="accent1"/>
+          </a:fillRef>
+          <a:effectRef idx="2">
+            <a:schemeClr val="accent1"/>
+          </a:effectRef>
+          <a:fontRef idx="minor">
+            <a:schemeClr val="lt1"/>
+          </a:fontRef>
+        </p:style>
+        <p:txBody>
+          <a:bodyPr rtlCol="0" anchor="ctr"/>
+          <a:lstStyle/>
+          <a:p>
+            <a:pPr algn="ctr"/>
+            <a:endParaRPr/>
+          </a:p>
+        </p:txBody>
+      </p:sp>
+      <p:sp>
+        <p:nvSpPr>
+          <p:cNvPr id="57" name="TextBox 56"/>
+          <p:cNvSpPr txBox="1"/>
+          <p:nvPr/>
+        </p:nvSpPr>
+        <p:spPr>
+          <a:xfrm>
+            <a:off x="343814" y="3561587"/>
+            <a:ext cx="237744" cy="228600"/>
+          </a:xfrm>
+          <a:prstGeom prst="rect">
+            <a:avLst/>
+          </a:prstGeom>
+          <a:noFill/>
+        </p:spPr>
+        <p:txBody>
+          <a:bodyPr wrap="square" lIns="0" tIns="0" rIns="0" bIns="0" anchor="ctr">
+            <a:spAutoFit/>
+          </a:bodyPr>
+          <a:lstStyle/>
+          <a:p>
+            <a:pPr algn="ctr">
+              <a:spcBef>
+                <a:spcPts val="0"/>
+              </a:spcBef>
+              <a:spcAft>
+                <a:spcPts val="0"/>
+              </a:spcAft>
+              <a:defRPr sz="1100" b="1">
+                <a:solidFill>
+                  <a:srgbClr val="FFFFFF"/>
+                </a:solidFill>
+                <a:latin typeface="Noto Sans CJK JP"/>
+              </a:defRPr>
+            </a:pPr>
+            <a:r>
+              <a:t>11</a:t>
+            </a:r>
+          </a:p>
+        </p:txBody>
+      </p:sp>
+      <p:cxnSp>
+        <p:nvCxnSpPr>
+          <p:cNvPr id="58" name="Connector 57"/>
+          <p:cNvCxnSpPr/>
+          <p:nvPr/>
+        </p:nvCxnSpPr>
+        <p:spPr>
+          <a:xfrm>
+            <a:off x="3136392" y="3685032"/>
+            <a:ext cx="1929384" cy="0"/>
+          </a:xfrm>
+          <a:prstGeom prst="line">
+            <a:avLst/>
+          </a:prstGeom>
+          <a:ln w="17780">
+            <a:solidFill>
+              <a:srgbClr val="077979"/>
+            </a:solidFill>
+          </a:ln>
+        </p:spPr>
+        <p:style>
+          <a:lnRef idx="2">
+            <a:schemeClr val="accent1"/>
+          </a:lnRef>
+          <a:fillRef idx="0">
+            <a:schemeClr val="accent1"/>
+          </a:fillRef>
+          <a:effectRef idx="1">
+            <a:schemeClr val="accent1"/>
+          </a:effectRef>
+          <a:fontRef idx="minor">
+            <a:schemeClr val="tx1"/>
+          </a:fontRef>
+        </p:style>
+      </p:cxnSp>
+      <p:sp>
+        <p:nvSpPr>
+          <p:cNvPr id="59" name="Isosceles Triangle 58"/>
+          <p:cNvSpPr/>
+          <p:nvPr/>
+        </p:nvSpPr>
+        <p:spPr>
+          <a:xfrm rot="5400000">
+            <a:off x="5022799" y="3642969"/>
+            <a:ext cx="86868" cy="86868"/>
+          </a:xfrm>
+          <a:prstGeom prst="triangle">
+            <a:avLst/>
+          </a:prstGeom>
+          <a:solidFill>
+            <a:srgbClr val="077979"/>
+          </a:solidFill>
+          <a:ln>
+            <a:noFill/>
+          </a:ln>
+        </p:spPr>
+        <p:style>
+          <a:lnRef idx="1">
+            <a:schemeClr val="accent1"/>
+          </a:lnRef>
+          <a:fillRef idx="3">
+            <a:schemeClr val="accent1"/>
+          </a:fillRef>
+          <a:effectRef idx="2">
+            <a:schemeClr val="accent1"/>
+          </a:effectRef>
+          <a:fontRef idx="minor">
+            <a:schemeClr val="lt1"/>
+          </a:fontRef>
+        </p:style>
+        <p:txBody>
+          <a:bodyPr rtlCol="0" anchor="ctr"/>
+          <a:lstStyle/>
+          <a:p>
+            <a:pPr algn="ctr"/>
+            <a:endParaRPr/>
+          </a:p>
+        </p:txBody>
+      </p:sp>
+      <p:sp>
+        <p:nvSpPr>
+          <p:cNvPr id="60" name="TextBox 59"/>
+          <p:cNvSpPr txBox="1"/>
+          <p:nvPr/>
+        </p:nvSpPr>
+        <p:spPr>
+          <a:xfrm>
+            <a:off x="3118104" y="3465576"/>
+            <a:ext cx="1911095" cy="210312"/>
+          </a:xfrm>
+          <a:prstGeom prst="rect">
+            <a:avLst/>
+          </a:prstGeom>
+          <a:noFill/>
+        </p:spPr>
+        <p:txBody>
+          <a:bodyPr wrap="square" lIns="0" tIns="0" rIns="0" bIns="0" anchor="ctr">
+            <a:spAutoFit/>
+          </a:bodyPr>
+          <a:lstStyle/>
+          <a:p>
+            <a:pPr algn="ctr">
+              <a:spcBef>
+                <a:spcPts val="0"/>
+              </a:spcBef>
+              <a:spcAft>
+                <a:spcPts val="0"/>
+              </a:spcAft>
+              <a:defRPr sz="1040" b="1">
+                <a:solidFill>
+                  <a:srgbClr val="1E354F"/>
+                </a:solidFill>
+                <a:latin typeface="Noto Sans CJK JP"/>
+              </a:defRPr>
+            </a:pPr>
+            <a:r>
+              <a:t>⑪ StartEvaluation(...)</a:t>
+            </a:r>
+          </a:p>
+        </p:txBody>
+      </p:sp>
+      <p:cxnSp>
+        <p:nvCxnSpPr>
+          <p:cNvPr id="61" name="Connector 60"/>
+          <p:cNvCxnSpPr/>
+          <p:nvPr/>
+        </p:nvCxnSpPr>
+        <p:spPr>
+          <a:xfrm>
+            <a:off x="5065776" y="4187952"/>
+            <a:ext cx="1920240" cy="0"/>
+          </a:xfrm>
+          <a:prstGeom prst="line">
+            <a:avLst/>
+          </a:prstGeom>
+          <a:ln w="17780">
+            <a:solidFill>
+              <a:srgbClr val="2E6FAF"/>
+            </a:solidFill>
+            <a:tailEnd type="triangle"/>
+          </a:ln>
+        </p:spPr>
+        <p:style>
+          <a:lnRef idx="2">
+            <a:schemeClr val="accent1"/>
+          </a:lnRef>
+          <a:fillRef idx="0">
+            <a:schemeClr val="accent1"/>
+          </a:fillRef>
+          <a:effectRef idx="1">
+            <a:schemeClr val="accent1"/>
+          </a:effectRef>
+          <a:fontRef idx="minor">
+            <a:schemeClr val="tx1"/>
+          </a:fontRef>
+        </p:style>
+      </p:cxnSp>
+      <p:sp>
+        <p:nvSpPr>
+          <p:cNvPr id="63" name="TextBox 62"/>
+          <p:cNvSpPr txBox="1"/>
+          <p:nvPr/>
+        </p:nvSpPr>
+        <p:spPr>
+          <a:xfrm>
+            <a:off x="5029199" y="3936492"/>
+            <a:ext cx="1856231" cy="219456"/>
+          </a:xfrm>
+          <a:prstGeom prst="rect">
+            <a:avLst/>
+          </a:prstGeom>
+          <a:noFill/>
+        </p:spPr>
+        <p:txBody>
+          <a:bodyPr wrap="square" lIns="0" tIns="0" rIns="0" bIns="0" anchor="ctr">
+            <a:spAutoFit/>
+          </a:bodyPr>
+          <a:lstStyle/>
+          <a:p>
+            <a:pPr algn="ctr">
+              <a:spcBef>
+                <a:spcPts val="0"/>
+              </a:spcBef>
+              <a:spcAft>
+                <a:spcPts val="0"/>
+              </a:spcAft>
+              <a:defRPr sz="1000" b="0">
+                <a:solidFill>
+                  <a:srgbClr val="1E354F"/>
+                </a:solidFill>
+                <a:latin typeface="Noto Sans CJK JP"/>
+              </a:defRPr>
+            </a:pPr>
+            <a:r>
+              <a:t>Y/Nの評価を要求</a:t>
+            </a:r>
+          </a:p>
+        </p:txBody>
+      </p:sp>
+      <p:cxnSp>
+        <p:nvCxnSpPr>
+          <p:cNvPr id="64" name="Connector 63"/>
+          <p:cNvCxnSpPr/>
+          <p:nvPr/>
+        </p:nvCxnSpPr>
+        <p:spPr>
+          <a:xfrm flipH="1">
+            <a:off x="5065776" y="4663440"/>
+            <a:ext cx="1920240" cy="0"/>
+          </a:xfrm>
+          <a:prstGeom prst="line">
+            <a:avLst/>
+          </a:prstGeom>
+          <a:ln w="17780">
+            <a:solidFill>
+              <a:srgbClr val="2E6FAF"/>
+            </a:solidFill>
+            <a:tailEnd type="triangle"/>
+          </a:ln>
+        </p:spPr>
+        <p:style>
+          <a:lnRef idx="2">
+            <a:schemeClr val="accent1"/>
+          </a:lnRef>
+          <a:fillRef idx="0">
+            <a:schemeClr val="accent1"/>
+          </a:fillRef>
+          <a:effectRef idx="1">
+            <a:schemeClr val="accent1"/>
+          </a:effectRef>
+          <a:fontRef idx="minor">
+            <a:schemeClr val="tx1"/>
+          </a:fontRef>
+        </p:style>
+      </p:cxnSp>
+      <p:sp>
+        <p:nvSpPr>
+          <p:cNvPr id="66" name="TextBox 65"/>
+          <p:cNvSpPr txBox="1"/>
+          <p:nvPr/>
+        </p:nvSpPr>
+        <p:spPr>
+          <a:xfrm>
+            <a:off x="5111496" y="4425696"/>
+            <a:ext cx="1865376" cy="201168"/>
+          </a:xfrm>
+          <a:prstGeom prst="rect">
+            <a:avLst/>
+          </a:prstGeom>
+          <a:noFill/>
+        </p:spPr>
+        <p:txBody>
+          <a:bodyPr wrap="square" lIns="0" tIns="0" rIns="0" bIns="0" anchor="ctr">
+            <a:spAutoFit/>
+          </a:bodyPr>
+          <a:lstStyle/>
+          <a:p>
+            <a:pPr algn="ctr">
+              <a:spcBef>
+                <a:spcPts val="0"/>
+              </a:spcBef>
+              <a:spcAft>
+                <a:spcPts val="0"/>
+              </a:spcAft>
+              <a:defRPr sz="1000" b="1">
+                <a:solidFill>
+                  <a:srgbClr val="077979"/>
+                </a:solidFill>
+                <a:latin typeface="Noto Sans CJK JP"/>
+              </a:defRPr>
+            </a:pPr>
+            <a:r>
+              <a:t>Y = correct（実測）</a:t>
+            </a:r>
+          </a:p>
+        </p:txBody>
+      </p:sp>
+      <p:sp>
+        <p:nvSpPr>
+          <p:cNvPr id="67" name="Oval 66"/>
+          <p:cNvSpPr/>
+          <p:nvPr/>
+        </p:nvSpPr>
+        <p:spPr>
+          <a:xfrm>
+            <a:off x="338328" y="5047488"/>
+            <a:ext cx="246888" cy="246888"/>
+          </a:xfrm>
+          <a:prstGeom prst="ellipse">
+            <a:avLst/>
+          </a:prstGeom>
+          <a:solidFill>
+            <a:srgbClr val="077979"/>
+          </a:solidFill>
+          <a:ln>
+            <a:noFill/>
+          </a:ln>
+        </p:spPr>
+        <p:style>
+          <a:lnRef idx="1">
+            <a:schemeClr val="accent1"/>
+          </a:lnRef>
+          <a:fillRef idx="3">
+            <a:schemeClr val="accent1"/>
+          </a:fillRef>
+          <a:effectRef idx="2">
+            <a:schemeClr val="accent1"/>
+          </a:effectRef>
+          <a:fontRef idx="minor">
+            <a:schemeClr val="lt1"/>
+          </a:fontRef>
+        </p:style>
+        <p:txBody>
+          <a:bodyPr rtlCol="0" anchor="ctr"/>
+          <a:lstStyle/>
+          <a:p>
+            <a:pPr algn="ctr"/>
+            <a:endParaRPr/>
+          </a:p>
+        </p:txBody>
+      </p:sp>
+      <p:sp>
+        <p:nvSpPr>
+          <p:cNvPr id="68" name="TextBox 67"/>
+          <p:cNvSpPr txBox="1"/>
+          <p:nvPr/>
+        </p:nvSpPr>
+        <p:spPr>
+          <a:xfrm>
+            <a:off x="343814" y="5052059"/>
+            <a:ext cx="237744" cy="228600"/>
+          </a:xfrm>
+          <a:prstGeom prst="rect">
+            <a:avLst/>
+          </a:prstGeom>
+          <a:noFill/>
+        </p:spPr>
+        <p:txBody>
+          <a:bodyPr wrap="square" lIns="0" tIns="0" rIns="0" bIns="0" anchor="ctr">
+            <a:spAutoFit/>
+          </a:bodyPr>
+          <a:lstStyle/>
+          <a:p>
+            <a:pPr algn="ctr">
+              <a:spcBef>
+                <a:spcPts val="0"/>
+              </a:spcBef>
+              <a:spcAft>
+                <a:spcPts val="0"/>
+              </a:spcAft>
+              <a:defRPr sz="1100" b="1">
+                <a:solidFill>
+                  <a:srgbClr val="FFFFFF"/>
+                </a:solidFill>
+                <a:latin typeface="Noto Sans CJK JP"/>
+              </a:defRPr>
+            </a:pPr>
+            <a:r>
+              <a:t>12</a:t>
+            </a:r>
+          </a:p>
+        </p:txBody>
+      </p:sp>
+      <p:cxnSp>
+        <p:nvCxnSpPr>
+          <p:cNvPr id="69" name="Connector 68"/>
+          <p:cNvCxnSpPr/>
+          <p:nvPr/>
+        </p:nvCxnSpPr>
+        <p:spPr>
+          <a:xfrm>
+            <a:off x="5065776" y="5129784"/>
+            <a:ext cx="3831336" cy="0"/>
+          </a:xfrm>
+          <a:prstGeom prst="line">
+            <a:avLst/>
+          </a:prstGeom>
+          <a:ln w="17780">
+            <a:solidFill>
+              <a:srgbClr val="077979"/>
+            </a:solidFill>
+          </a:ln>
+        </p:spPr>
+        <p:style>
+          <a:lnRef idx="2">
+            <a:schemeClr val="accent1"/>
+          </a:lnRef>
+          <a:fillRef idx="0">
+            <a:schemeClr val="accent1"/>
+          </a:fillRef>
+          <a:effectRef idx="1">
+            <a:schemeClr val="accent1"/>
+          </a:effectRef>
+          <a:fontRef idx="minor">
+            <a:schemeClr val="tx1"/>
+          </a:fontRef>
+        </p:style>
+      </p:cxnSp>
+      <p:sp>
+        <p:nvSpPr>
+          <p:cNvPr id="70" name="Isosceles Triangle 69"/>
+          <p:cNvSpPr/>
+          <p:nvPr/>
+        </p:nvSpPr>
+        <p:spPr>
+          <a:xfrm rot="5400000">
+            <a:off x="8854135" y="5087721"/>
+            <a:ext cx="86868" cy="86868"/>
+          </a:xfrm>
+          <a:prstGeom prst="triangle">
+            <a:avLst/>
+          </a:prstGeom>
+          <a:solidFill>
+            <a:srgbClr val="077979"/>
+          </a:solidFill>
+          <a:ln>
+            <a:noFill/>
+          </a:ln>
+        </p:spPr>
+        <p:style>
+          <a:lnRef idx="1">
+            <a:schemeClr val="accent1"/>
+          </a:lnRef>
+          <a:fillRef idx="3">
+            <a:schemeClr val="accent1"/>
+          </a:fillRef>
+          <a:effectRef idx="2">
+            <a:schemeClr val="accent1"/>
+          </a:effectRef>
+          <a:fontRef idx="minor">
+            <a:schemeClr val="lt1"/>
+          </a:fontRef>
+        </p:style>
+        <p:txBody>
+          <a:bodyPr rtlCol="0" anchor="ctr"/>
+          <a:lstStyle/>
+          <a:p>
+            <a:pPr algn="ctr"/>
+            <a:endParaRPr/>
+          </a:p>
+        </p:txBody>
+      </p:sp>
+      <p:sp>
+        <p:nvSpPr>
+          <p:cNvPr id="71" name="TextBox 70"/>
+          <p:cNvSpPr txBox="1"/>
+          <p:nvPr/>
+        </p:nvSpPr>
+        <p:spPr>
+          <a:xfrm>
+            <a:off x="5175504" y="4910328"/>
+            <a:ext cx="3566160" cy="201168"/>
+          </a:xfrm>
+          <a:prstGeom prst="rect">
+            <a:avLst/>
+          </a:prstGeom>
+          <a:noFill/>
+        </p:spPr>
+        <p:txBody>
+          <a:bodyPr wrap="square" lIns="0" tIns="0" rIns="0" bIns="0" anchor="ctr">
+            <a:spAutoFit/>
+          </a:bodyPr>
+          <a:lstStyle/>
+          <a:p>
+            <a:pPr algn="ctr">
+              <a:spcBef>
+                <a:spcPts val="0"/>
+              </a:spcBef>
+              <a:spcAft>
+                <a:spcPts val="0"/>
+              </a:spcAft>
+              <a:defRPr sz="1030" b="1">
+                <a:solidFill>
+                  <a:srgbClr val="1E354F"/>
+                </a:solidFill>
+                <a:latin typeface="Noto Sans CJK JP"/>
+              </a:defRPr>
+            </a:pPr>
+            <a:r>
+              <a:t>⑫ SaveExperience(request, 0, true, "correct")</a:t>
+            </a:r>
+          </a:p>
+        </p:txBody>
+      </p:sp>
+      <p:cxnSp>
+        <p:nvCxnSpPr>
+          <p:cNvPr id="72" name="Connector 71"/>
+          <p:cNvCxnSpPr/>
+          <p:nvPr/>
+        </p:nvCxnSpPr>
+        <p:spPr>
+          <a:xfrm>
+            <a:off x="8897112" y="5532120"/>
+            <a:ext cx="1874520" cy="0"/>
+          </a:xfrm>
+          <a:prstGeom prst="line">
+            <a:avLst/>
+          </a:prstGeom>
+          <a:ln w="17780">
+            <a:solidFill>
+              <a:srgbClr val="077979"/>
+            </a:solidFill>
+          </a:ln>
+        </p:spPr>
+        <p:style>
+          <a:lnRef idx="2">
+            <a:schemeClr val="accent1"/>
+          </a:lnRef>
+          <a:fillRef idx="0">
+            <a:schemeClr val="accent1"/>
+          </a:fillRef>
+          <a:effectRef idx="1">
+            <a:schemeClr val="accent1"/>
+          </a:effectRef>
+          <a:fontRef idx="minor">
+            <a:schemeClr val="tx1"/>
+          </a:fontRef>
+        </p:style>
+      </p:cxnSp>
+      <p:sp>
+        <p:nvSpPr>
+          <p:cNvPr id="73" name="Isosceles Triangle 72"/>
+          <p:cNvSpPr/>
+          <p:nvPr/>
+        </p:nvSpPr>
+        <p:spPr>
+          <a:xfrm rot="5400000">
+            <a:off x="10728655" y="5490057"/>
+            <a:ext cx="86868" cy="86868"/>
+          </a:xfrm>
+          <a:prstGeom prst="triangle">
+            <a:avLst/>
+          </a:prstGeom>
+          <a:solidFill>
+            <a:srgbClr val="077979"/>
+          </a:solidFill>
+          <a:ln>
+            <a:noFill/>
+          </a:ln>
+        </p:spPr>
+        <p:style>
+          <a:lnRef idx="1">
+            <a:schemeClr val="accent1"/>
+          </a:lnRef>
+          <a:fillRef idx="3">
+            <a:schemeClr val="accent1"/>
+          </a:fillRef>
+          <a:effectRef idx="2">
+            <a:schemeClr val="accent1"/>
+          </a:effectRef>
+          <a:fontRef idx="minor">
+            <a:schemeClr val="lt1"/>
+          </a:fontRef>
+        </p:style>
+        <p:txBody>
+          <a:bodyPr rtlCol="0" anchor="ctr"/>
+          <a:lstStyle/>
+          <a:p>
+            <a:pPr algn="ctr"/>
+            <a:endParaRPr/>
+          </a:p>
+        </p:txBody>
+      </p:sp>
+      <p:sp>
+        <p:nvSpPr>
+          <p:cNvPr id="74" name="TextBox 73"/>
+          <p:cNvSpPr txBox="1"/>
+          <p:nvPr/>
+        </p:nvSpPr>
+        <p:spPr>
+          <a:xfrm>
+            <a:off x="8842248" y="5312664"/>
+            <a:ext cx="1920240" cy="201168"/>
+          </a:xfrm>
+          <a:prstGeom prst="rect">
+            <a:avLst/>
+          </a:prstGeom>
+          <a:noFill/>
+        </p:spPr>
+        <p:txBody>
+          <a:bodyPr wrap="square" lIns="0" tIns="0" rIns="0" bIns="0" anchor="ctr">
+            <a:spAutoFit/>
+          </a:bodyPr>
+          <a:lstStyle/>
+          <a:p>
+            <a:pPr algn="ctr">
+              <a:spcBef>
+                <a:spcPts val="0"/>
+              </a:spcBef>
+              <a:spcAft>
+                <a:spcPts val="0"/>
+              </a:spcAft>
+              <a:defRPr sz="1010" b="1">
+                <a:solidFill>
+                  <a:srgbClr val="077979"/>
+                </a:solidFill>
+                <a:latin typeface="Noto Sans CJK JP"/>
+              </a:defRPr>
+            </a:pPr>
+            <a:r>
+              <a:t>JSONLへ1行追記</a:t>
+            </a:r>
+          </a:p>
+        </p:txBody>
+      </p:sp>
+      <p:cxnSp>
+        <p:nvCxnSpPr>
+          <p:cNvPr id="75" name="Connector 74"/>
+          <p:cNvCxnSpPr/>
+          <p:nvPr/>
+        </p:nvCxnSpPr>
+        <p:spPr>
+          <a:xfrm>
+            <a:off x="466344" y="5769864"/>
+            <a:ext cx="11219688" cy="0"/>
+          </a:xfrm>
+          <a:prstGeom prst="line">
+            <a:avLst/>
+          </a:prstGeom>
+          <a:ln w="12700">
+            <a:solidFill>
+              <a:srgbClr val="DFE9F2"/>
+            </a:solidFill>
+          </a:ln>
+        </p:spPr>
+        <p:style>
+          <a:lnRef idx="2">
+            <a:schemeClr val="accent1"/>
+          </a:lnRef>
+          <a:fillRef idx="0">
+            <a:schemeClr val="accent1"/>
+          </a:fillRef>
+          <a:effectRef idx="1">
+            <a:schemeClr val="accent1"/>
+          </a:effectRef>
+          <a:fontRef idx="minor">
+            <a:schemeClr val="tx1"/>
+          </a:fontRef>
+        </p:style>
+      </p:cxnSp>
+      <p:sp>
+        <p:nvSpPr>
+          <p:cNvPr id="76" name="Rounded Rectangle 75"/>
+          <p:cNvSpPr/>
+          <p:nvPr/>
+        </p:nvSpPr>
+        <p:spPr>
+          <a:xfrm>
+            <a:off x="475488" y="5879592"/>
+            <a:ext cx="5577840" cy="658368"/>
+          </a:xfrm>
+          <a:prstGeom prst="roundRect">
+            <a:avLst>
+              <a:gd name="adj" fmla="val 13000"/>
+            </a:avLst>
+          </a:prstGeom>
+          <a:solidFill>
+            <a:srgbClr val="E3F6F4"/>
+          </a:solidFill>
+          <a:ln w="10160">
+            <a:solidFill>
+              <a:srgbClr val="BBDDD7"/>
+            </a:solidFill>
+          </a:ln>
+        </p:spPr>
+        <p:style>
+          <a:lnRef idx="1">
+            <a:schemeClr val="accent1"/>
+          </a:lnRef>
+          <a:fillRef idx="3">
+            <a:schemeClr val="accent1"/>
+          </a:fillRef>
+          <a:effectRef idx="2">
+            <a:schemeClr val="accent1"/>
+          </a:effectRef>
+          <a:fontRef idx="minor">
+            <a:schemeClr val="lt1"/>
+          </a:fontRef>
+        </p:style>
+        <p:txBody>
+          <a:bodyPr rtlCol="0" anchor="ctr"/>
+          <a:lstStyle/>
+          <a:p>
+            <a:pPr algn="ctr"/>
+            <a:endParaRPr/>
+          </a:p>
+        </p:txBody>
+      </p:sp>
+      <p:sp>
+        <p:nvSpPr>
+          <p:cNvPr id="77" name="Rounded Rectangle 76"/>
+          <p:cNvSpPr/>
+          <p:nvPr/>
+        </p:nvSpPr>
+        <p:spPr>
+          <a:xfrm>
+            <a:off x="594360" y="5980176"/>
+            <a:ext cx="704088" cy="228600"/>
+          </a:xfrm>
+          <a:prstGeom prst="roundRect">
+            <a:avLst>
+              <a:gd name="adj" fmla="val 13000"/>
+            </a:avLst>
+          </a:prstGeom>
+          <a:solidFill>
+            <a:srgbClr val="077979"/>
+          </a:solidFill>
+          <a:ln>
+            <a:noFill/>
+          </a:ln>
+        </p:spPr>
+        <p:style>
+          <a:lnRef idx="1">
+            <a:schemeClr val="accent1"/>
+          </a:lnRef>
+          <a:fillRef idx="3">
+            <a:schemeClr val="accent1"/>
+          </a:fillRef>
+          <a:effectRef idx="2">
+            <a:schemeClr val="accent1"/>
+          </a:effectRef>
+          <a:fontRef idx="minor">
+            <a:schemeClr val="lt1"/>
+          </a:fontRef>
+        </p:style>
+        <p:txBody>
+          <a:bodyPr rtlCol="0" anchor="ctr"/>
+          <a:lstStyle/>
+          <a:p>
+            <a:pPr algn="ctr"/>
+            <a:endParaRPr/>
+          </a:p>
+        </p:txBody>
+      </p:sp>
+      <p:sp>
+        <p:nvSpPr>
+          <p:cNvPr id="78" name="TextBox 77"/>
+          <p:cNvSpPr txBox="1"/>
+          <p:nvPr/>
+        </p:nvSpPr>
+        <p:spPr>
+          <a:xfrm>
+            <a:off x="616305" y="5980176"/>
+            <a:ext cx="658368" cy="228600"/>
+          </a:xfrm>
+          <a:prstGeom prst="rect">
+            <a:avLst/>
+          </a:prstGeom>
+          <a:noFill/>
+        </p:spPr>
+        <p:txBody>
+          <a:bodyPr wrap="square" lIns="0" tIns="0" rIns="0" bIns="0" anchor="ctr">
+            <a:spAutoFit/>
+          </a:bodyPr>
+          <a:lstStyle/>
+          <a:p>
+            <a:pPr algn="ctr">
+              <a:spcBef>
+                <a:spcPts val="0"/>
+              </a:spcBef>
+              <a:spcAft>
+                <a:spcPts val="0"/>
+              </a:spcAft>
+              <a:defRPr sz="950" b="1">
+                <a:solidFill>
+                  <a:srgbClr val="FFFFFF"/>
+                </a:solidFill>
+                <a:latin typeface="Noto Sans CJK JP"/>
+              </a:defRPr>
+            </a:pPr>
+            <a:r>
+              <a:t>実測</a:t>
+            </a:r>
+          </a:p>
+        </p:txBody>
+      </p:sp>
+      <p:sp>
+        <p:nvSpPr>
+          <p:cNvPr id="79" name="TextBox 78"/>
+          <p:cNvSpPr txBox="1"/>
+          <p:nvPr/>
+        </p:nvSpPr>
+        <p:spPr>
+          <a:xfrm>
+            <a:off x="1426464" y="5907024"/>
+            <a:ext cx="4480560" cy="603504"/>
+          </a:xfrm>
+          <a:prstGeom prst="rect">
+            <a:avLst/>
+          </a:prstGeom>
+          <a:noFill/>
+        </p:spPr>
+        <p:txBody>
+          <a:bodyPr wrap="square" lIns="0" tIns="0" rIns="0" bIns="0" anchor="ctr">
+            <a:spAutoFit/>
+          </a:bodyPr>
+          <a:lstStyle/>
+          <a:p>
+            <a:pPr algn="l">
+              <a:spcBef>
+                <a:spcPts val="0"/>
+              </a:spcBef>
+              <a:spcAft>
+                <a:spcPts val="0"/>
+              </a:spcAft>
+              <a:defRPr sz="1015" b="0">
+                <a:solidFill>
+                  <a:srgbClr val="1E354F"/>
+                </a:solidFill>
+                <a:latin typeface="Noto Sans CJK JP"/>
+              </a:defRPr>
+            </a:pPr>
+            <a:r>
+              <a:t>right / Error=0 / Verification=PASS</a:t>
+            </a:r>
+          </a:p>
+          <a:p>
+            <a:pPr algn="l">
+              <a:spcBef>
+                <a:spcPts val="0"/>
+              </a:spcBef>
+              <a:spcAft>
+                <a:spcPts val="0"/>
+              </a:spcAft>
+              <a:defRPr sz="1015" b="0">
+                <a:solidFill>
+                  <a:srgbClr val="1E354F"/>
+                </a:solidFill>
+                <a:latin typeface="Noto Sans CJK JP"/>
+              </a:defRPr>
+            </a:pPr>
+            <a:r>
+              <a:t>Y=correct → JSONL 3件から4件へ（23:53:33）</a:t>
+            </a:r>
+          </a:p>
+        </p:txBody>
+      </p:sp>
+      <p:sp>
+        <p:nvSpPr>
+          <p:cNvPr id="80" name="Rounded Rectangle 79"/>
+          <p:cNvSpPr/>
+          <p:nvPr/>
+        </p:nvSpPr>
+        <p:spPr>
+          <a:xfrm>
+            <a:off x="6199632" y="5879592"/>
+            <a:ext cx="5468112" cy="658368"/>
+          </a:xfrm>
+          <a:prstGeom prst="roundRect">
+            <a:avLst>
+              <a:gd name="adj" fmla="val 13000"/>
+            </a:avLst>
+          </a:prstGeom>
+          <a:solidFill>
+            <a:srgbClr val="FFF7E1"/>
+          </a:solidFill>
+          <a:ln w="10160">
+            <a:solidFill>
+              <a:srgbClr val="EAD8AF"/>
+            </a:solidFill>
+          </a:ln>
+        </p:spPr>
+        <p:style>
+          <a:lnRef idx="1">
+            <a:schemeClr val="accent1"/>
+          </a:lnRef>
+          <a:fillRef idx="3">
+            <a:schemeClr val="accent1"/>
+          </a:fillRef>
+          <a:effectRef idx="2">
+            <a:schemeClr val="accent1"/>
+          </a:effectRef>
+          <a:fontRef idx="minor">
+            <a:schemeClr val="lt1"/>
+          </a:fontRef>
+        </p:style>
+        <p:txBody>
+          <a:bodyPr rtlCol="0" anchor="ctr"/>
+          <a:lstStyle/>
+          <a:p>
+            <a:pPr algn="ctr"/>
+            <a:endParaRPr/>
+          </a:p>
+        </p:txBody>
+      </p:sp>
+      <p:sp>
+        <p:nvSpPr>
+          <p:cNvPr id="81" name="Rounded Rectangle 80"/>
+          <p:cNvSpPr/>
+          <p:nvPr/>
+        </p:nvSpPr>
+        <p:spPr>
+          <a:xfrm>
+            <a:off x="6318504" y="5980176"/>
+            <a:ext cx="822960" cy="228600"/>
+          </a:xfrm>
+          <a:prstGeom prst="roundRect">
+            <a:avLst>
+              <a:gd name="adj" fmla="val 13000"/>
+            </a:avLst>
+          </a:prstGeom>
+          <a:solidFill>
+            <a:srgbClr val="B5751E"/>
+          </a:solidFill>
+          <a:ln>
+            <a:noFill/>
+          </a:ln>
+        </p:spPr>
+        <p:style>
+          <a:lnRef idx="1">
+            <a:schemeClr val="accent1"/>
+          </a:lnRef>
+          <a:fillRef idx="3">
+            <a:schemeClr val="accent1"/>
+          </a:fillRef>
+          <a:effectRef idx="2">
+            <a:schemeClr val="accent1"/>
+          </a:effectRef>
+          <a:fontRef idx="minor">
+            <a:schemeClr val="lt1"/>
+          </a:fontRef>
+        </p:style>
+        <p:txBody>
+          <a:bodyPr rtlCol="0" anchor="ctr"/>
+          <a:lstStyle/>
+          <a:p>
+            <a:pPr algn="ctr"/>
+            <a:endParaRPr/>
+          </a:p>
+        </p:txBody>
+      </p:sp>
+      <p:sp>
+        <p:nvSpPr>
+          <p:cNvPr id="82" name="TextBox 81"/>
+          <p:cNvSpPr txBox="1"/>
+          <p:nvPr/>
+        </p:nvSpPr>
+        <p:spPr>
+          <a:xfrm>
+            <a:off x="6336792" y="5980176"/>
+            <a:ext cx="777240" cy="228600"/>
+          </a:xfrm>
+          <a:prstGeom prst="rect">
+            <a:avLst/>
+          </a:prstGeom>
+          <a:noFill/>
+        </p:spPr>
+        <p:txBody>
+          <a:bodyPr wrap="square" lIns="0" tIns="0" rIns="0" bIns="0" anchor="ctr">
+            <a:spAutoFit/>
+          </a:bodyPr>
+          <a:lstStyle/>
+          <a:p>
+            <a:pPr algn="ctr">
+              <a:spcBef>
+                <a:spcPts val="0"/>
+              </a:spcBef>
+              <a:spcAft>
+                <a:spcPts val="0"/>
+              </a:spcAft>
+              <a:defRPr sz="950" b="1">
+                <a:solidFill>
+                  <a:srgbClr val="FFFFFF"/>
+                </a:solidFill>
+                <a:latin typeface="Noto Sans CJK JP"/>
+              </a:defRPr>
+            </a:pPr>
+            <a:r>
+              <a:t>未検証</a:t>
+            </a:r>
+          </a:p>
+        </p:txBody>
+      </p:sp>
+      <p:sp>
+        <p:nvSpPr>
+          <p:cNvPr id="83" name="TextBox 82"/>
+          <p:cNvSpPr txBox="1"/>
+          <p:nvPr/>
+        </p:nvSpPr>
+        <p:spPr>
+          <a:xfrm>
+            <a:off x="7260336" y="5907024"/>
+            <a:ext cx="4315968" cy="603504"/>
+          </a:xfrm>
+          <a:prstGeom prst="rect">
+            <a:avLst/>
+          </a:prstGeom>
+          <a:noFill/>
+        </p:spPr>
+        <p:txBody>
+          <a:bodyPr wrap="square" lIns="0" tIns="0" rIns="0" bIns="0" anchor="ctr">
+            <a:spAutoFit/>
+          </a:bodyPr>
+          <a:lstStyle/>
+          <a:p>
+            <a:pPr algn="l">
+              <a:spcBef>
+                <a:spcPts val="0"/>
+              </a:spcBef>
+              <a:spcAft>
+                <a:spcPts val="0"/>
+              </a:spcAft>
+              <a:defRPr sz="1015" b="0">
+                <a:solidFill>
+                  <a:srgbClr val="1E354F"/>
+                </a:solidFill>
+                <a:latin typeface="Noto Sans CJK JP"/>
+              </a:defRPr>
+            </a:pPr>
+            <a:r>
+              <a:t>FAIL / incorrect / 通信失敗時の保存</a:t>
+            </a:r>
+          </a:p>
+          <a:p>
+            <a:pPr algn="l">
+              <a:spcBef>
+                <a:spcPts val="0"/>
+              </a:spcBef>
+              <a:spcAft>
+                <a:spcPts val="0"/>
+              </a:spcAft>
+              <a:defRPr sz="1015" b="0">
+                <a:solidFill>
+                  <a:srgbClr val="1E354F"/>
+                </a:solidFill>
+                <a:latin typeface="Noto Sans CJK JP"/>
+              </a:defRPr>
+            </a:pPr>
+            <a:r>
+              <a:t>送信成功ACKの独立判定は未実装</a:t>
+            </a:r>
+          </a:p>
+        </p:txBody>
+      </p:sp>
+      <p:sp>
+        <p:nvSpPr>
+          <p:cNvPr id="84" name="TextBox 83"/>
+          <p:cNvSpPr txBox="1"/>
+          <p:nvPr/>
+        </p:nvSpPr>
+        <p:spPr>
+          <a:xfrm>
+            <a:off x="502920" y="6601968"/>
+            <a:ext cx="11247120" cy="164592"/>
+          </a:xfrm>
+          <a:prstGeom prst="rect">
+            <a:avLst/>
+          </a:prstGeom>
+          <a:noFill/>
+        </p:spPr>
+        <p:txBody>
+          <a:bodyPr wrap="square" lIns="0" tIns="0" rIns="0" bIns="0" anchor="ctr">
+            <a:spAutoFit/>
+          </a:bodyPr>
+          <a:lstStyle/>
+          <a:p>
+            <a:pPr algn="l">
+              <a:spcBef>
+                <a:spcPts val="0"/>
+              </a:spcBef>
+              <a:spcAft>
+                <a:spcPts val="0"/>
+              </a:spcAft>
+              <a:defRPr sz="780" b="0">
+                <a:solidFill>
+                  <a:srgbClr val="5B6E82"/>
+                </a:solidFill>
+                <a:latin typeface="Noto Sans CJK JP"/>
+              </a:defRPr>
+            </a:pPr>
+            <a:r>
+              <a:t>注：実測は成功ケース1件。10月2日の既存3記録は保持。AIR経由の移動・検証・評価・保存を区別し、実行ファイルと提示ソースの厳密な同一性は未確認。</a:t>
+            </a:r>
+          </a:p>
+        </p:txBody>
+      </p:sp>
+      <p:cxnSp>
+        <p:nvCxnSpPr>
+          <p:cNvPr id="15" name="Connector 14"/>
+          <p:cNvCxnSpPr/>
+          <p:nvPr/>
+        </p:nvCxnSpPr>
+        <p:spPr>
+          <a:xfrm>
+            <a:off x="1225296" y="2313432"/>
+            <a:ext cx="0" cy="3392424"/>
+          </a:xfrm>
+          <a:prstGeom prst="line">
+            <a:avLst/>
+          </a:prstGeom>
+          <a:ln w="12700">
+            <a:solidFill>
+              <a:srgbClr val="DFE9F2"/>
+            </a:solidFill>
+            <a:prstDash val="dash"/>
+          </a:ln>
+        </p:spPr>
+        <p:style>
+          <a:lnRef idx="2">
+            <a:schemeClr val="accent1"/>
+          </a:lnRef>
+          <a:fillRef idx="0">
+            <a:schemeClr val="accent1"/>
+          </a:fillRef>
+          <a:effectRef idx="1">
+            <a:schemeClr val="accent1"/>
+          </a:effectRef>
+          <a:fontRef idx="minor">
+            <a:schemeClr val="tx1"/>
+          </a:fontRef>
+        </p:style>
+      </p:cxnSp>
+      <p:cxnSp>
+        <p:nvCxnSpPr>
+          <p:cNvPr id="19" name="Connector 18"/>
+          <p:cNvCxnSpPr/>
+          <p:nvPr/>
+        </p:nvCxnSpPr>
+        <p:spPr>
+          <a:xfrm>
+            <a:off x="3136392" y="2313432"/>
+            <a:ext cx="0" cy="3392424"/>
+          </a:xfrm>
+          <a:prstGeom prst="line">
+            <a:avLst/>
+          </a:prstGeom>
+          <a:ln w="12700">
+            <a:solidFill>
+              <a:srgbClr val="DFE9F2"/>
+            </a:solidFill>
+            <a:prstDash val="dash"/>
+          </a:ln>
+        </p:spPr>
+        <p:style>
+          <a:lnRef idx="2">
+            <a:schemeClr val="accent1"/>
+          </a:lnRef>
+          <a:fillRef idx="0">
+            <a:schemeClr val="accent1"/>
+          </a:fillRef>
+          <a:effectRef idx="1">
+            <a:schemeClr val="accent1"/>
+          </a:effectRef>
+          <a:fontRef idx="minor">
+            <a:schemeClr val="tx1"/>
+          </a:fontRef>
+        </p:style>
+      </p:cxnSp>
+      <p:cxnSp>
+        <p:nvCxnSpPr>
+          <p:cNvPr id="23" name="Connector 22"/>
+          <p:cNvCxnSpPr/>
+          <p:nvPr/>
+        </p:nvCxnSpPr>
+        <p:spPr>
+          <a:xfrm>
+            <a:off x="5065776" y="2313432"/>
+            <a:ext cx="0" cy="3392424"/>
+          </a:xfrm>
+          <a:prstGeom prst="line">
+            <a:avLst/>
+          </a:prstGeom>
+          <a:ln w="12700">
+            <a:solidFill>
+              <a:srgbClr val="DFE9F2"/>
+            </a:solidFill>
+            <a:prstDash val="dash"/>
+          </a:ln>
+        </p:spPr>
+        <p:style>
+          <a:lnRef idx="2">
+            <a:schemeClr val="accent1"/>
+          </a:lnRef>
+          <a:fillRef idx="0">
+            <a:schemeClr val="accent1"/>
+          </a:fillRef>
+          <a:effectRef idx="1">
+            <a:schemeClr val="accent1"/>
+          </a:effectRef>
+          <a:fontRef idx="minor">
+            <a:schemeClr val="tx1"/>
+          </a:fontRef>
+        </p:style>
+      </p:cxnSp>
+      <p:cxnSp>
+        <p:nvCxnSpPr>
+          <p:cNvPr id="27" name="Connector 26"/>
+          <p:cNvCxnSpPr/>
+          <p:nvPr/>
+        </p:nvCxnSpPr>
+        <p:spPr>
+          <a:xfrm>
+            <a:off x="6986016" y="2313432"/>
+            <a:ext cx="0" cy="3392424"/>
+          </a:xfrm>
+          <a:prstGeom prst="line">
+            <a:avLst/>
+          </a:prstGeom>
+          <a:ln w="12700">
+            <a:solidFill>
+              <a:srgbClr val="DFE9F2"/>
+            </a:solidFill>
+            <a:prstDash val="dash"/>
+          </a:ln>
+        </p:spPr>
+        <p:style>
+          <a:lnRef idx="2">
+            <a:schemeClr val="accent1"/>
+          </a:lnRef>
+          <a:fillRef idx="0">
+            <a:schemeClr val="accent1"/>
+          </a:fillRef>
+          <a:effectRef idx="1">
+            <a:schemeClr val="accent1"/>
+          </a:effectRef>
+          <a:fontRef idx="minor">
+            <a:schemeClr val="tx1"/>
+          </a:fontRef>
+        </p:style>
+      </p:cxnSp>
+      <p:cxnSp>
+        <p:nvCxnSpPr>
+          <p:cNvPr id="31" name="Connector 30"/>
+          <p:cNvCxnSpPr/>
+          <p:nvPr/>
+        </p:nvCxnSpPr>
+        <p:spPr>
+          <a:xfrm>
+            <a:off x="8897112" y="2313432"/>
+            <a:ext cx="0" cy="3392424"/>
+          </a:xfrm>
+          <a:prstGeom prst="line">
+            <a:avLst/>
+          </a:prstGeom>
+          <a:ln w="12700">
+            <a:solidFill>
+              <a:srgbClr val="DFE9F2"/>
+            </a:solidFill>
+            <a:prstDash val="dash"/>
+          </a:ln>
+        </p:spPr>
+        <p:style>
+          <a:lnRef idx="2">
+            <a:schemeClr val="accent1"/>
+          </a:lnRef>
+          <a:fillRef idx="0">
+            <a:schemeClr val="accent1"/>
+          </a:fillRef>
+          <a:effectRef idx="1">
+            <a:schemeClr val="accent1"/>
+          </a:effectRef>
+          <a:fontRef idx="minor">
+            <a:schemeClr val="tx1"/>
+          </a:fontRef>
+        </p:style>
+      </p:cxnSp>
+      <p:cxnSp>
+        <p:nvCxnSpPr>
+          <p:cNvPr id="35" name="Connector 34"/>
+          <p:cNvCxnSpPr/>
+          <p:nvPr/>
+        </p:nvCxnSpPr>
+        <p:spPr>
+          <a:xfrm>
+            <a:off x="10771632" y="2313432"/>
+            <a:ext cx="0" cy="3392424"/>
+          </a:xfrm>
+          <a:prstGeom prst="line">
+            <a:avLst/>
+          </a:prstGeom>
+          <a:ln w="12700">
+            <a:solidFill>
+              <a:srgbClr val="DFE9F2"/>
+            </a:solidFill>
+            <a:prstDash val="dash"/>
+          </a:ln>
+        </p:spPr>
+        <p:style>
+          <a:lnRef idx="2">
+            <a:schemeClr val="accent1"/>
+          </a:lnRef>
+          <a:fillRef idx="0">
+            <a:schemeClr val="accent1"/>
+          </a:fillRef>
+          <a:effectRef idx="1">
+            <a:schemeClr val="accent1"/>
+          </a:effectRef>
+          <a:fontRef idx="minor">
+            <a:schemeClr val="tx1"/>
+          </a:fontRef>
+        </p:style>
+      </p:cxnSp>
     </p:spTree>
   </p:cSld>
   <p:clrMapOvr>

</xml_diff>